<commit_message>
Add the literature review section to the deck
Two slides plus a divider, inserted after the problem section, because the
deck went straight from the problem to the system with no literature review
at all and the team needs one for the presentation.

First slide: what each of the three sources contributes and why three were
needed, with the standards consulted alongside. Second slide: the three
existing approaches to design automation, what each solves and what each
leaves open, and the gap this work addresses.

26 slides now, sections renumbered.
</commit_message>
<xml_diff>
--- a/report/AI-in-CAD-Major-Project-Presentation.pptx
+++ b/report/AI-in-CAD-Major-Project-Presentation.pptx
@@ -28,6 +28,9 @@
     <p:sldId id="276" r:id="rId27"/>
     <p:sldId id="277" r:id="rId28"/>
     <p:sldId id="278" r:id="rId29"/>
+    <p:sldId id="279" r:id="rId30"/>
+    <p:sldId id="280" r:id="rId31"/>
+    <p:sldId id="281" r:id="rId32"/>
   </p:sldIdLst>
   <p:sldSz cx="12191695" cy="6858000" type="screen4x3"/>
   <p:notesSz cx="6858000" cy="9144000"/>
@@ -3743,6 +3746,132 @@
       <p:pic>
         <p:nvPicPr>
           <p:cNvPr id="2" name="Picture 1" descr="s-23.png"/>
+          <p:cNvPicPr>
+            <a:picLocks noChangeAspect="1"/>
+          </p:cNvPicPr>
+          <p:nvPr/>
+        </p:nvPicPr>
+        <p:blipFill>
+          <a:blip r:embed="rId2"/>
+          <a:stretch>
+            <a:fillRect/>
+          </a:stretch>
+        </p:blipFill>
+        <p:spPr>
+          <a:xfrm>
+            <a:off x="0" y="0"/>
+            <a:ext cx="12191695" cy="6858000"/>
+          </a:xfrm>
+          <a:prstGeom prst="rect">
+            <a:avLst/>
+          </a:prstGeom>
+        </p:spPr>
+      </p:pic>
+    </p:spTree>
+  </p:cSld>
+  <p:clrMapOvr>
+    <a:masterClrMapping/>
+  </p:clrMapOvr>
+</p:sld>
+</file>
+
+<file path=ppt/slides/slide24.xml><?xml version="1.0" encoding="utf-8"?>
+<p:sld xmlns:a="http://schemas.openxmlformats.org/drawingml/2006/main" xmlns:p="http://schemas.openxmlformats.org/presentationml/2006/main" xmlns:r="http://schemas.openxmlformats.org/officeDocument/2006/relationships">
+  <p:cSld>
+    <p:spTree>
+      <p:nvGrpSpPr>
+        <p:cNvPr id="1" name=""/>
+        <p:cNvGrpSpPr/>
+        <p:nvPr/>
+      </p:nvGrpSpPr>
+      <p:grpSpPr/>
+      <p:pic>
+        <p:nvPicPr>
+          <p:cNvPr id="2" name="Picture 1" descr="s-24.png"/>
+          <p:cNvPicPr>
+            <a:picLocks noChangeAspect="1"/>
+          </p:cNvPicPr>
+          <p:nvPr/>
+        </p:nvPicPr>
+        <p:blipFill>
+          <a:blip r:embed="rId2"/>
+          <a:stretch>
+            <a:fillRect/>
+          </a:stretch>
+        </p:blipFill>
+        <p:spPr>
+          <a:xfrm>
+            <a:off x="0" y="0"/>
+            <a:ext cx="12191695" cy="6858000"/>
+          </a:xfrm>
+          <a:prstGeom prst="rect">
+            <a:avLst/>
+          </a:prstGeom>
+        </p:spPr>
+      </p:pic>
+    </p:spTree>
+  </p:cSld>
+  <p:clrMapOvr>
+    <a:masterClrMapping/>
+  </p:clrMapOvr>
+</p:sld>
+</file>
+
+<file path=ppt/slides/slide25.xml><?xml version="1.0" encoding="utf-8"?>
+<p:sld xmlns:a="http://schemas.openxmlformats.org/drawingml/2006/main" xmlns:p="http://schemas.openxmlformats.org/presentationml/2006/main" xmlns:r="http://schemas.openxmlformats.org/officeDocument/2006/relationships">
+  <p:cSld>
+    <p:spTree>
+      <p:nvGrpSpPr>
+        <p:cNvPr id="1" name=""/>
+        <p:cNvGrpSpPr/>
+        <p:nvPr/>
+      </p:nvGrpSpPr>
+      <p:grpSpPr/>
+      <p:pic>
+        <p:nvPicPr>
+          <p:cNvPr id="2" name="Picture 1" descr="s-25.png"/>
+          <p:cNvPicPr>
+            <a:picLocks noChangeAspect="1"/>
+          </p:cNvPicPr>
+          <p:nvPr/>
+        </p:nvPicPr>
+        <p:blipFill>
+          <a:blip r:embed="rId2"/>
+          <a:stretch>
+            <a:fillRect/>
+          </a:stretch>
+        </p:blipFill>
+        <p:spPr>
+          <a:xfrm>
+            <a:off x="0" y="0"/>
+            <a:ext cx="12191695" cy="6858000"/>
+          </a:xfrm>
+          <a:prstGeom prst="rect">
+            <a:avLst/>
+          </a:prstGeom>
+        </p:spPr>
+      </p:pic>
+    </p:spTree>
+  </p:cSld>
+  <p:clrMapOvr>
+    <a:masterClrMapping/>
+  </p:clrMapOvr>
+</p:sld>
+</file>
+
+<file path=ppt/slides/slide26.xml><?xml version="1.0" encoding="utf-8"?>
+<p:sld xmlns:a="http://schemas.openxmlformats.org/drawingml/2006/main" xmlns:p="http://schemas.openxmlformats.org/presentationml/2006/main" xmlns:r="http://schemas.openxmlformats.org/officeDocument/2006/relationships">
+  <p:cSld>
+    <p:spTree>
+      <p:nvGrpSpPr>
+        <p:cNvPr id="1" name=""/>
+        <p:cNvGrpSpPr/>
+        <p:nvPr/>
+      </p:nvGrpSpPr>
+      <p:grpSpPr/>
+      <p:pic>
+        <p:nvPicPr>
+          <p:cNvPr id="2" name="Picture 1" descr="s-26.png"/>
           <p:cNvPicPr>
             <a:picLocks noChangeAspect="1"/>
           </p:cNvPicPr>

</xml_diff>

<commit_message>
Speaker notes on every slide of the PowerPoint
One note per slide, 26 in all, each opening with who presents it so nobody has
to remember the split: Ansh 1 to 6, Bhavya 7 to 10, Atishay 11 to 17,
Dharmendra 18 to 21, Ankur 22 to 26.

Written to be glanced at while speaking rather than read out, and carrying the
answers to the questions each slide invites, such as why the AI is not allowed
to choose a dimension and why nothing sits at a hundred percent of allowable.
</commit_message>
<xml_diff>
--- a/report/AI-in-CAD-Major-Project-Presentation.pptx
+++ b/report/AI-in-CAD-Major-Project-Presentation.pptx
@@ -6,31 +6,31 @@
   </p:sldMasterIdLst>
   <p:sldIdLst>
     <p:sldId id="256" r:id="rId7"/>
-    <p:sldId id="257" r:id="rId8"/>
-    <p:sldId id="258" r:id="rId9"/>
-    <p:sldId id="259" r:id="rId10"/>
-    <p:sldId id="260" r:id="rId11"/>
-    <p:sldId id="261" r:id="rId12"/>
-    <p:sldId id="262" r:id="rId13"/>
-    <p:sldId id="263" r:id="rId14"/>
-    <p:sldId id="264" r:id="rId15"/>
-    <p:sldId id="265" r:id="rId16"/>
-    <p:sldId id="266" r:id="rId17"/>
-    <p:sldId id="267" r:id="rId18"/>
-    <p:sldId id="268" r:id="rId19"/>
-    <p:sldId id="269" r:id="rId20"/>
-    <p:sldId id="270" r:id="rId21"/>
-    <p:sldId id="271" r:id="rId22"/>
-    <p:sldId id="272" r:id="rId23"/>
-    <p:sldId id="273" r:id="rId24"/>
-    <p:sldId id="274" r:id="rId25"/>
-    <p:sldId id="275" r:id="rId26"/>
-    <p:sldId id="276" r:id="rId27"/>
-    <p:sldId id="277" r:id="rId28"/>
-    <p:sldId id="278" r:id="rId29"/>
-    <p:sldId id="279" r:id="rId30"/>
-    <p:sldId id="280" r:id="rId31"/>
-    <p:sldId id="281" r:id="rId32"/>
+    <p:sldId id="257" r:id="rId9"/>
+    <p:sldId id="258" r:id="rId10"/>
+    <p:sldId id="259" r:id="rId11"/>
+    <p:sldId id="260" r:id="rId12"/>
+    <p:sldId id="261" r:id="rId13"/>
+    <p:sldId id="262" r:id="rId14"/>
+    <p:sldId id="263" r:id="rId15"/>
+    <p:sldId id="264" r:id="rId16"/>
+    <p:sldId id="265" r:id="rId17"/>
+    <p:sldId id="266" r:id="rId18"/>
+    <p:sldId id="267" r:id="rId19"/>
+    <p:sldId id="268" r:id="rId20"/>
+    <p:sldId id="269" r:id="rId21"/>
+    <p:sldId id="270" r:id="rId22"/>
+    <p:sldId id="271" r:id="rId23"/>
+    <p:sldId id="272" r:id="rId24"/>
+    <p:sldId id="273" r:id="rId25"/>
+    <p:sldId id="274" r:id="rId26"/>
+    <p:sldId id="275" r:id="rId27"/>
+    <p:sldId id="276" r:id="rId28"/>
+    <p:sldId id="277" r:id="rId29"/>
+    <p:sldId id="278" r:id="rId30"/>
+    <p:sldId id="279" r:id="rId31"/>
+    <p:sldId id="280" r:id="rId32"/>
+    <p:sldId id="281" r:id="rId33"/>
   </p:sldIdLst>
   <p:sldSz cx="12191695" cy="6858000" type="screen4x3"/>
   <p:notesSz cx="6858000" cy="9144000"/>
@@ -130,6 +130,2866 @@
     </a:lvl9pPr>
   </p:defaultTextStyle>
 </p:presentation>
+</file>
+
+<file path=ppt/notesMasters/notesMaster1.xml><?xml version="1.0" encoding="utf-8"?>
+<p:notesMaster xmlns:a="http://schemas.openxmlformats.org/drawingml/2006/main" xmlns:p="http://schemas.openxmlformats.org/presentationml/2006/main" xmlns:r="http://schemas.openxmlformats.org/officeDocument/2006/relationships">
+  <p:cSld>
+    <p:bg>
+      <p:bgRef idx="1001">
+        <a:schemeClr val="bg1"/>
+      </p:bgRef>
+    </p:bg>
+    <p:spTree>
+      <p:nvGrpSpPr>
+        <p:cNvPr id="1" name=""/>
+        <p:cNvGrpSpPr/>
+        <p:nvPr/>
+      </p:nvGrpSpPr>
+      <p:grpSpPr>
+        <a:xfrm>
+          <a:off x="0" y="0"/>
+          <a:ext cx="0" cy="0"/>
+          <a:chOff x="0" y="0"/>
+          <a:chExt cx="0" cy="0"/>
+        </a:xfrm>
+      </p:grpSpPr>
+      <p:sp>
+        <p:nvSpPr>
+          <p:cNvPr id="2" name="Header Placeholder 1"/>
+          <p:cNvSpPr>
+            <a:spLocks noGrp="1"/>
+          </p:cNvSpPr>
+          <p:nvPr>
+            <p:ph type="hdr" sz="quarter"/>
+          </p:nvPr>
+        </p:nvSpPr>
+        <p:spPr>
+          <a:xfrm>
+            <a:off x="0" y="0"/>
+            <a:ext cx="2971800" cy="457200"/>
+          </a:xfrm>
+          <a:prstGeom prst="rect">
+            <a:avLst/>
+          </a:prstGeom>
+        </p:spPr>
+        <p:txBody>
+          <a:bodyPr vert="horz" lIns="91440" tIns="45720" rIns="91440" bIns="45720" rtlCol="0"/>
+          <a:lstStyle>
+            <a:lvl1pPr algn="l">
+              <a:defRPr sz="1200"/>
+            </a:lvl1pPr>
+          </a:lstStyle>
+          <a:p>
+            <a:endParaRPr lang="en-US"/>
+          </a:p>
+        </p:txBody>
+      </p:sp>
+      <p:sp>
+        <p:nvSpPr>
+          <p:cNvPr id="3" name="Date Placeholder 2"/>
+          <p:cNvSpPr>
+            <a:spLocks noGrp="1"/>
+          </p:cNvSpPr>
+          <p:nvPr>
+            <p:ph type="dt" idx="1"/>
+          </p:nvPr>
+        </p:nvSpPr>
+        <p:spPr>
+          <a:xfrm>
+            <a:off x="3884613" y="0"/>
+            <a:ext cx="2971800" cy="457200"/>
+          </a:xfrm>
+          <a:prstGeom prst="rect">
+            <a:avLst/>
+          </a:prstGeom>
+        </p:spPr>
+        <p:txBody>
+          <a:bodyPr vert="horz" lIns="91440" tIns="45720" rIns="91440" bIns="45720" rtlCol="0"/>
+          <a:lstStyle>
+            <a:lvl1pPr algn="r">
+              <a:defRPr sz="1200"/>
+            </a:lvl1pPr>
+          </a:lstStyle>
+          <a:p>
+            <a:fld id="{0F89C1C7-3DCD-1040-A9CF-14679D8B5DDD}" type="datetimeFigureOut">
+              <a:rPr lang="en-US" smtClean="0"/>
+              <a:t>10/17/16</a:t>
+            </a:fld>
+            <a:endParaRPr lang="en-US"/>
+          </a:p>
+        </p:txBody>
+      </p:sp>
+      <p:sp>
+        <p:nvSpPr>
+          <p:cNvPr id="4" name="Slide Image Placeholder 3"/>
+          <p:cNvSpPr>
+            <a:spLocks noGrp="1" noRot="1" noChangeAspect="1"/>
+          </p:cNvSpPr>
+          <p:nvPr>
+            <p:ph type="sldImg" idx="2"/>
+          </p:nvPr>
+        </p:nvSpPr>
+        <p:spPr>
+          <a:xfrm>
+            <a:off x="1143000" y="685800"/>
+            <a:ext cx="4572000" cy="3429000"/>
+          </a:xfrm>
+          <a:prstGeom prst="rect">
+            <a:avLst/>
+          </a:prstGeom>
+          <a:noFill/>
+          <a:ln w="12700">
+            <a:solidFill>
+              <a:prstClr val="black"/>
+            </a:solidFill>
+          </a:ln>
+        </p:spPr>
+        <p:txBody>
+          <a:bodyPr vert="horz" lIns="91440" tIns="45720" rIns="91440" bIns="45720" rtlCol="0" anchor="ctr"/>
+          <a:lstStyle/>
+          <a:p>
+            <a:endParaRPr lang="en-US"/>
+          </a:p>
+        </p:txBody>
+      </p:sp>
+      <p:sp>
+        <p:nvSpPr>
+          <p:cNvPr id="5" name="Notes Placeholder 4"/>
+          <p:cNvSpPr>
+            <a:spLocks noGrp="1"/>
+          </p:cNvSpPr>
+          <p:nvPr>
+            <p:ph type="body" sz="quarter" idx="3"/>
+          </p:nvPr>
+        </p:nvSpPr>
+        <p:spPr>
+          <a:xfrm>
+            <a:off x="685800" y="4343400"/>
+            <a:ext cx="5486400" cy="4114800"/>
+          </a:xfrm>
+          <a:prstGeom prst="rect">
+            <a:avLst/>
+          </a:prstGeom>
+        </p:spPr>
+        <p:txBody>
+          <a:bodyPr vert="horz" lIns="91440" tIns="45720" rIns="91440" bIns="45720" rtlCol="0"/>
+          <a:lstStyle/>
+          <a:p>
+            <a:pPr lvl="0"/>
+            <a:r>
+              <a:rPr lang="en-US" smtClean="0"/>
+              <a:t>Click to edit Master text styles</a:t>
+            </a:r>
+          </a:p>
+          <a:p>
+            <a:pPr lvl="1"/>
+            <a:r>
+              <a:rPr lang="en-US" smtClean="0"/>
+              <a:t>Second level</a:t>
+            </a:r>
+          </a:p>
+          <a:p>
+            <a:pPr lvl="2"/>
+            <a:r>
+              <a:rPr lang="en-US" smtClean="0"/>
+              <a:t>Third level</a:t>
+            </a:r>
+          </a:p>
+          <a:p>
+            <a:pPr lvl="3"/>
+            <a:r>
+              <a:rPr lang="en-US" smtClean="0"/>
+              <a:t>Fourth level</a:t>
+            </a:r>
+          </a:p>
+          <a:p>
+            <a:pPr lvl="4"/>
+            <a:r>
+              <a:rPr lang="en-US" smtClean="0"/>
+              <a:t>Fifth level</a:t>
+            </a:r>
+            <a:endParaRPr lang="en-US"/>
+          </a:p>
+        </p:txBody>
+      </p:sp>
+      <p:sp>
+        <p:nvSpPr>
+          <p:cNvPr id="6" name="Footer Placeholder 5"/>
+          <p:cNvSpPr>
+            <a:spLocks noGrp="1"/>
+          </p:cNvSpPr>
+          <p:nvPr>
+            <p:ph type="ftr" sz="quarter" idx="4"/>
+          </p:nvPr>
+        </p:nvSpPr>
+        <p:spPr>
+          <a:xfrm>
+            <a:off x="0" y="8685213"/>
+            <a:ext cx="2971800" cy="457200"/>
+          </a:xfrm>
+          <a:prstGeom prst="rect">
+            <a:avLst/>
+          </a:prstGeom>
+        </p:spPr>
+        <p:txBody>
+          <a:bodyPr vert="horz" lIns="91440" tIns="45720" rIns="91440" bIns="45720" rtlCol="0" anchor="b"/>
+          <a:lstStyle>
+            <a:lvl1pPr algn="l">
+              <a:defRPr sz="1200"/>
+            </a:lvl1pPr>
+          </a:lstStyle>
+          <a:p>
+            <a:endParaRPr lang="en-US"/>
+          </a:p>
+        </p:txBody>
+      </p:sp>
+      <p:sp>
+        <p:nvSpPr>
+          <p:cNvPr id="7" name="Slide Number Placeholder 6"/>
+          <p:cNvSpPr>
+            <a:spLocks noGrp="1"/>
+          </p:cNvSpPr>
+          <p:nvPr>
+            <p:ph type="sldNum" sz="quarter" idx="5"/>
+          </p:nvPr>
+        </p:nvSpPr>
+        <p:spPr>
+          <a:xfrm>
+            <a:off x="3884613" y="8685213"/>
+            <a:ext cx="2971800" cy="457200"/>
+          </a:xfrm>
+          <a:prstGeom prst="rect">
+            <a:avLst/>
+          </a:prstGeom>
+        </p:spPr>
+        <p:txBody>
+          <a:bodyPr vert="horz" lIns="91440" tIns="45720" rIns="91440" bIns="45720" rtlCol="0" anchor="b"/>
+          <a:lstStyle>
+            <a:lvl1pPr algn="r">
+              <a:defRPr sz="1200"/>
+            </a:lvl1pPr>
+          </a:lstStyle>
+          <a:p>
+            <a:fld id="{BB5E49A5-4136-284D-997B-48E1D791AD67}" type="slidenum">
+              <a:rPr lang="en-US" smtClean="0"/>
+              <a:t>‹#›</a:t>
+            </a:fld>
+            <a:endParaRPr lang="en-US"/>
+          </a:p>
+        </p:txBody>
+      </p:sp>
+    </p:spTree>
+    <p:extLst>
+      <p:ext uri="{BB962C8B-B14F-4D97-AF65-F5344CB8AC3E}">
+        <p14:creationId xmlns:p14="http://schemas.microsoft.com/office/powerpoint/2010/main" val="2623252185"/>
+      </p:ext>
+    </p:extLst>
+  </p:cSld>
+  <p:clrMap bg1="lt1" tx1="dk1" bg2="lt2" tx2="dk2" accent1="accent1" accent2="accent2" accent3="accent3" accent4="accent4" accent5="accent5" accent6="accent6" hlink="hlink" folHlink="folHlink"/>
+  <p:notesStyle>
+    <a:lvl1pPr marL="0" algn="l" defTabSz="457200" rtl="0" eaLnBrk="1" latinLnBrk="0" hangingPunct="1">
+      <a:defRPr sz="1200" kern="1200">
+        <a:solidFill>
+          <a:schemeClr val="tx1"/>
+        </a:solidFill>
+        <a:latin typeface="+mn-lt"/>
+        <a:ea typeface="+mn-ea"/>
+        <a:cs typeface="+mn-cs"/>
+      </a:defRPr>
+    </a:lvl1pPr>
+    <a:lvl2pPr marL="457200" algn="l" defTabSz="457200" rtl="0" eaLnBrk="1" latinLnBrk="0" hangingPunct="1">
+      <a:defRPr sz="1200" kern="1200">
+        <a:solidFill>
+          <a:schemeClr val="tx1"/>
+        </a:solidFill>
+        <a:latin typeface="+mn-lt"/>
+        <a:ea typeface="+mn-ea"/>
+        <a:cs typeface="+mn-cs"/>
+      </a:defRPr>
+    </a:lvl2pPr>
+    <a:lvl3pPr marL="914400" algn="l" defTabSz="457200" rtl="0" eaLnBrk="1" latinLnBrk="0" hangingPunct="1">
+      <a:defRPr sz="1200" kern="1200">
+        <a:solidFill>
+          <a:schemeClr val="tx1"/>
+        </a:solidFill>
+        <a:latin typeface="+mn-lt"/>
+        <a:ea typeface="+mn-ea"/>
+        <a:cs typeface="+mn-cs"/>
+      </a:defRPr>
+    </a:lvl3pPr>
+    <a:lvl4pPr marL="1371600" algn="l" defTabSz="457200" rtl="0" eaLnBrk="1" latinLnBrk="0" hangingPunct="1">
+      <a:defRPr sz="1200" kern="1200">
+        <a:solidFill>
+          <a:schemeClr val="tx1"/>
+        </a:solidFill>
+        <a:latin typeface="+mn-lt"/>
+        <a:ea typeface="+mn-ea"/>
+        <a:cs typeface="+mn-cs"/>
+      </a:defRPr>
+    </a:lvl4pPr>
+    <a:lvl5pPr marL="1828800" algn="l" defTabSz="457200" rtl="0" eaLnBrk="1" latinLnBrk="0" hangingPunct="1">
+      <a:defRPr sz="1200" kern="1200">
+        <a:solidFill>
+          <a:schemeClr val="tx1"/>
+        </a:solidFill>
+        <a:latin typeface="+mn-lt"/>
+        <a:ea typeface="+mn-ea"/>
+        <a:cs typeface="+mn-cs"/>
+      </a:defRPr>
+    </a:lvl5pPr>
+    <a:lvl6pPr marL="2286000" algn="l" defTabSz="457200" rtl="0" eaLnBrk="1" latinLnBrk="0" hangingPunct="1">
+      <a:defRPr sz="1200" kern="1200">
+        <a:solidFill>
+          <a:schemeClr val="tx1"/>
+        </a:solidFill>
+        <a:latin typeface="+mn-lt"/>
+        <a:ea typeface="+mn-ea"/>
+        <a:cs typeface="+mn-cs"/>
+      </a:defRPr>
+    </a:lvl6pPr>
+    <a:lvl7pPr marL="2743200" algn="l" defTabSz="457200" rtl="0" eaLnBrk="1" latinLnBrk="0" hangingPunct="1">
+      <a:defRPr sz="1200" kern="1200">
+        <a:solidFill>
+          <a:schemeClr val="tx1"/>
+        </a:solidFill>
+        <a:latin typeface="+mn-lt"/>
+        <a:ea typeface="+mn-ea"/>
+        <a:cs typeface="+mn-cs"/>
+      </a:defRPr>
+    </a:lvl7pPr>
+    <a:lvl8pPr marL="3200400" algn="l" defTabSz="457200" rtl="0" eaLnBrk="1" latinLnBrk="0" hangingPunct="1">
+      <a:defRPr sz="1200" kern="1200">
+        <a:solidFill>
+          <a:schemeClr val="tx1"/>
+        </a:solidFill>
+        <a:latin typeface="+mn-lt"/>
+        <a:ea typeface="+mn-ea"/>
+        <a:cs typeface="+mn-cs"/>
+      </a:defRPr>
+    </a:lvl8pPr>
+    <a:lvl9pPr marL="3657600" algn="l" defTabSz="457200" rtl="0" eaLnBrk="1" latinLnBrk="0" hangingPunct="1">
+      <a:defRPr sz="1200" kern="1200">
+        <a:solidFill>
+          <a:schemeClr val="tx1"/>
+        </a:solidFill>
+        <a:latin typeface="+mn-lt"/>
+        <a:ea typeface="+mn-ea"/>
+        <a:cs typeface="+mn-cs"/>
+      </a:defRPr>
+    </a:lvl9pPr>
+  </p:notesStyle>
+</p:notesMaster>
+</file>
+
+<file path=ppt/notesSlides/notesSlide1.xml><?xml version="1.0" encoding="utf-8"?>
+<p:notes xmlns:a="http://schemas.openxmlformats.org/drawingml/2006/main" xmlns:p="http://schemas.openxmlformats.org/presentationml/2006/main" xmlns:r="http://schemas.openxmlformats.org/officeDocument/2006/relationships">
+  <p:cSld>
+    <p:spTree>
+      <p:nvGrpSpPr>
+        <p:cNvPr id="1" name=""/>
+        <p:cNvGrpSpPr/>
+        <p:nvPr/>
+      </p:nvGrpSpPr>
+      <p:grpSpPr>
+        <a:xfrm>
+          <a:off x="0" y="0"/>
+          <a:ext cx="0" cy="0"/>
+          <a:chOff x="0" y="0"/>
+          <a:chExt cx="0" cy="0"/>
+        </a:xfrm>
+      </p:grpSpPr>
+      <p:sp>
+        <p:nvSpPr>
+          <p:cNvPr id="2" name="Slide Image Placeholder 1"/>
+          <p:cNvSpPr>
+            <a:spLocks noGrp="1"/>
+          </p:cNvSpPr>
+          <p:nvPr>
+            <p:ph type="sldImg" idx="2"/>
+          </p:nvPr>
+        </p:nvSpPr>
+        <p:spPr/>
+      </p:sp>
+      <p:sp>
+        <p:nvSpPr>
+          <p:cNvPr id="3" name="Notes Placeholder 2"/>
+          <p:cNvSpPr>
+            <a:spLocks noGrp="1"/>
+          </p:cNvSpPr>
+          <p:nvPr>
+            <p:ph type="body" idx="3" sz="quarter"/>
+          </p:nvPr>
+        </p:nvSpPr>
+        <p:spPr/>
+        <p:txBody>
+          <a:bodyPr/>
+          <a:lstStyle/>
+          <a:p>
+            <a:r>
+              <a:t>ANSH.</a:t>
+            </a:r>
+          </a:p>
+          <a:p>
+            <a:r>
+              <a:t>Good morning. Our major project is the Strategic Application of Artificial Intelligence in CAD.</a:t>
+            </a:r>
+          </a:p>
+          <a:p>
+            <a:r>
+              <a:t>We are five: Ankur, myself, Atishay, Bhavya and Dharmendra, guided by Dr. Rawal.</a:t>
+            </a:r>
+          </a:p>
+          <a:p>
+            <a:r>
+              <a:t>In one line: you type a sentence like "knuckle joint for 50 kN", and the software designs that</a:t>
+            </a:r>
+          </a:p>
+          <a:p>
+            <a:r>
+              <a:t>joint completely, checks every way it can break, builds the 3D parts and draws the sheet. It</a:t>
+            </a:r>
+          </a:p>
+          <a:p>
+            <a:r>
+              <a:t>takes about ten seconds.</a:t>
+            </a:r>
+          </a:p>
+          <a:p>
+            <a:r>
+              <a:t>I will cover the problem and the literature. Bhavya takes what we built, Atishay the worked</a:t>
+            </a:r>
+          </a:p>
+          <a:p>
+            <a:r>
+              <a:t>example and the output, Dharmendra the verification, Ankur the validation.</a:t>
+            </a:r>
+          </a:p>
+        </p:txBody>
+      </p:sp>
+      <p:sp>
+        <p:nvSpPr>
+          <p:cNvPr id="4" name="Slide Number Placeholder 3"/>
+          <p:cNvSpPr>
+            <a:spLocks noGrp="1"/>
+          </p:cNvSpPr>
+          <p:nvPr>
+            <p:ph type="sldNum" idx="5" sz="quarter"/>
+          </p:nvPr>
+        </p:nvSpPr>
+        <p:spPr/>
+      </p:sp>
+    </p:spTree>
+  </p:cSld>
+  <p:clrMapOvr>
+    <a:masterClrMapping/>
+  </p:clrMapOvr>
+</p:notes>
+</file>
+
+<file path=ppt/notesSlides/notesSlide10.xml><?xml version="1.0" encoding="utf-8"?>
+<p:notes xmlns:a="http://schemas.openxmlformats.org/drawingml/2006/main" xmlns:p="http://schemas.openxmlformats.org/presentationml/2006/main" xmlns:r="http://schemas.openxmlformats.org/officeDocument/2006/relationships">
+  <p:cSld>
+    <p:spTree>
+      <p:nvGrpSpPr>
+        <p:cNvPr id="1" name=""/>
+        <p:cNvGrpSpPr/>
+        <p:nvPr/>
+      </p:nvGrpSpPr>
+      <p:grpSpPr>
+        <a:xfrm>
+          <a:off x="0" y="0"/>
+          <a:ext cx="0" cy="0"/>
+          <a:chOff x="0" y="0"/>
+          <a:chExt cx="0" cy="0"/>
+        </a:xfrm>
+      </p:grpSpPr>
+      <p:sp>
+        <p:nvSpPr>
+          <p:cNvPr id="2" name="Slide Image Placeholder 1"/>
+          <p:cNvSpPr>
+            <a:spLocks noGrp="1"/>
+          </p:cNvSpPr>
+          <p:nvPr>
+            <p:ph type="sldImg" idx="2"/>
+          </p:nvPr>
+        </p:nvSpPr>
+        <p:spPr/>
+      </p:sp>
+      <p:sp>
+        <p:nvSpPr>
+          <p:cNvPr id="3" name="Notes Placeholder 2"/>
+          <p:cNvSpPr>
+            <a:spLocks noGrp="1"/>
+          </p:cNvSpPr>
+          <p:nvPr>
+            <p:ph type="body" idx="3" sz="quarter"/>
+          </p:nvPr>
+        </p:nvSpPr>
+        <p:spPr/>
+        <p:txBody>
+          <a:bodyPr/>
+          <a:lstStyle/>
+          <a:p>
+            <a:r>
+              <a:t>BHAVYA.</a:t>
+            </a:r>
+          </a:p>
+          <a:p>
+            <a:r>
+              <a:t>Six joints, 44 failure checks in total, and every check is satisfied.</a:t>
+            </a:r>
+          </a:p>
+          <a:p>
+            <a:r>
+              <a:t>The busiest check across all six sits between 67 and 79 percent of allowable. That is</a:t>
+            </a:r>
+          </a:p>
+          <a:p>
+            <a:r>
+              <a:t>deliberate, not luck: each joint is sized for 1.25 times the load you asked for, then the</a:t>
+            </a:r>
+          </a:p>
+          <a:p>
+            <a:r>
+              <a:t>stresses are reported at the real load. Margin stays in hand rather than being spent on paper.</a:t>
+            </a:r>
+          </a:p>
+          <a:p>
+            <a:r>
+              <a:t>The gib and cotter joint needed a decision. Unwin gives the breadth and thickness but no strap</a:t>
+            </a:r>
+          </a:p>
+          <a:p>
+            <a:r>
+              <a:t>proportions. Rather than borrow a ratio from elsewhere or invent one, every dimension the source</a:t>
+            </a:r>
+          </a:p>
+          <a:p>
+            <a:r>
+              <a:t>does not give is sized against a failure check until it passes.</a:t>
+            </a:r>
+          </a:p>
+        </p:txBody>
+      </p:sp>
+      <p:sp>
+        <p:nvSpPr>
+          <p:cNvPr id="4" name="Slide Number Placeholder 3"/>
+          <p:cNvSpPr>
+            <a:spLocks noGrp="1"/>
+          </p:cNvSpPr>
+          <p:nvPr>
+            <p:ph type="sldNum" idx="5" sz="quarter"/>
+          </p:nvPr>
+        </p:nvSpPr>
+        <p:spPr/>
+      </p:sp>
+    </p:spTree>
+  </p:cSld>
+  <p:clrMapOvr>
+    <a:masterClrMapping/>
+  </p:clrMapOvr>
+</p:notes>
+</file>
+
+<file path=ppt/notesSlides/notesSlide11.xml><?xml version="1.0" encoding="utf-8"?>
+<p:notes xmlns:a="http://schemas.openxmlformats.org/drawingml/2006/main" xmlns:p="http://schemas.openxmlformats.org/presentationml/2006/main" xmlns:r="http://schemas.openxmlformats.org/officeDocument/2006/relationships">
+  <p:cSld>
+    <p:spTree>
+      <p:nvGrpSpPr>
+        <p:cNvPr id="1" name=""/>
+        <p:cNvGrpSpPr/>
+        <p:nvPr/>
+      </p:nvGrpSpPr>
+      <p:grpSpPr>
+        <a:xfrm>
+          <a:off x="0" y="0"/>
+          <a:ext cx="0" cy="0"/>
+          <a:chOff x="0" y="0"/>
+          <a:chExt cx="0" cy="0"/>
+        </a:xfrm>
+      </p:grpSpPr>
+      <p:sp>
+        <p:nvSpPr>
+          <p:cNvPr id="2" name="Slide Image Placeholder 1"/>
+          <p:cNvSpPr>
+            <a:spLocks noGrp="1"/>
+          </p:cNvSpPr>
+          <p:nvPr>
+            <p:ph type="sldImg" idx="2"/>
+          </p:nvPr>
+        </p:nvSpPr>
+        <p:spPr/>
+      </p:sp>
+      <p:sp>
+        <p:nvSpPr>
+          <p:cNvPr id="3" name="Notes Placeholder 2"/>
+          <p:cNvSpPr>
+            <a:spLocks noGrp="1"/>
+          </p:cNvSpPr>
+          <p:nvPr>
+            <p:ph type="body" idx="3" sz="quarter"/>
+          </p:nvPr>
+        </p:nvSpPr>
+        <p:spPr/>
+        <p:txBody>
+          <a:bodyPr/>
+          <a:lstStyle/>
+          <a:p>
+            <a:r>
+              <a:t>ATISHAY. Section opener. Say: let me take one joint end to end, with real numbers.</a:t>
+            </a:r>
+          </a:p>
+        </p:txBody>
+      </p:sp>
+      <p:sp>
+        <p:nvSpPr>
+          <p:cNvPr id="4" name="Slide Number Placeholder 3"/>
+          <p:cNvSpPr>
+            <a:spLocks noGrp="1"/>
+          </p:cNvSpPr>
+          <p:nvPr>
+            <p:ph type="sldNum" idx="5" sz="quarter"/>
+          </p:nvPr>
+        </p:nvSpPr>
+        <p:spPr/>
+      </p:sp>
+    </p:spTree>
+  </p:cSld>
+  <p:clrMapOvr>
+    <a:masterClrMapping/>
+  </p:clrMapOvr>
+</p:notes>
+</file>
+
+<file path=ppt/notesSlides/notesSlide12.xml><?xml version="1.0" encoding="utf-8"?>
+<p:notes xmlns:a="http://schemas.openxmlformats.org/drawingml/2006/main" xmlns:p="http://schemas.openxmlformats.org/presentationml/2006/main" xmlns:r="http://schemas.openxmlformats.org/officeDocument/2006/relationships">
+  <p:cSld>
+    <p:spTree>
+      <p:nvGrpSpPr>
+        <p:cNvPr id="1" name=""/>
+        <p:cNvGrpSpPr/>
+        <p:nvPr/>
+      </p:nvGrpSpPr>
+      <p:grpSpPr>
+        <a:xfrm>
+          <a:off x="0" y="0"/>
+          <a:ext cx="0" cy="0"/>
+          <a:chOff x="0" y="0"/>
+          <a:chExt cx="0" cy="0"/>
+        </a:xfrm>
+      </p:grpSpPr>
+      <p:sp>
+        <p:nvSpPr>
+          <p:cNvPr id="2" name="Slide Image Placeholder 1"/>
+          <p:cNvSpPr>
+            <a:spLocks noGrp="1"/>
+          </p:cNvSpPr>
+          <p:nvPr>
+            <p:ph type="sldImg" idx="2"/>
+          </p:nvPr>
+        </p:nvSpPr>
+        <p:spPr/>
+      </p:sp>
+      <p:sp>
+        <p:nvSpPr>
+          <p:cNvPr id="3" name="Notes Placeholder 2"/>
+          <p:cNvSpPr>
+            <a:spLocks noGrp="1"/>
+          </p:cNvSpPr>
+          <p:nvPr>
+            <p:ph type="body" idx="3" sz="quarter"/>
+          </p:nvPr>
+        </p:nvSpPr>
+        <p:spPr/>
+        <p:txBody>
+          <a:bodyPr/>
+          <a:lstStyle/>
+          <a:p>
+            <a:r>
+              <a:t>ATISHAY.</a:t>
+            </a:r>
+          </a:p>
+          <a:p>
+            <a:r>
+              <a:t>Knuckle joint, 50 kN. Three calculations decide everything.</a:t>
+            </a:r>
+          </a:p>
+          <a:p>
+            <a:r>
+              <a:t>Rod from direct tension gives 32.57, so the rod becomes 35, the next standard size.</a:t>
+            </a:r>
+          </a:p>
+          <a:p>
+            <a:r>
+              <a:t>The pin is sized twice. Double shear asks for 25.75. Bending asks for 43.72. We take the larger,</a:t>
+            </a:r>
+          </a:p>
+          <a:p>
+            <a:r>
+              <a:t>so the pin becomes 45.</a:t>
+            </a:r>
+          </a:p>
+          <a:p>
+            <a:r>
+              <a:t>Bending asks for nearly 1.7 times what shear asks for. A pin sized on shear alone would pass its</a:t>
+            </a:r>
+          </a:p>
+          <a:p>
+            <a:r>
+              <a:t>own check and bend in service. The textbook takes the same step.</a:t>
+            </a:r>
+          </a:p>
+          <a:p>
+            <a:r>
+              <a:t>Everything else follows from the rod diameter using the book proportions, each with its source</a:t>
+            </a:r>
+          </a:p>
+          <a:p>
+            <a:r>
+              <a:t>printed beside it.</a:t>
+            </a:r>
+          </a:p>
+        </p:txBody>
+      </p:sp>
+      <p:sp>
+        <p:nvSpPr>
+          <p:cNvPr id="4" name="Slide Number Placeholder 3"/>
+          <p:cNvSpPr>
+            <a:spLocks noGrp="1"/>
+          </p:cNvSpPr>
+          <p:nvPr>
+            <p:ph type="sldNum" idx="5" sz="quarter"/>
+          </p:nvPr>
+        </p:nvSpPr>
+        <p:spPr/>
+      </p:sp>
+    </p:spTree>
+  </p:cSld>
+  <p:clrMapOvr>
+    <a:masterClrMapping/>
+  </p:clrMapOvr>
+</p:notes>
+</file>
+
+<file path=ppt/notesSlides/notesSlide13.xml><?xml version="1.0" encoding="utf-8"?>
+<p:notes xmlns:a="http://schemas.openxmlformats.org/drawingml/2006/main" xmlns:p="http://schemas.openxmlformats.org/presentationml/2006/main" xmlns:r="http://schemas.openxmlformats.org/officeDocument/2006/relationships">
+  <p:cSld>
+    <p:spTree>
+      <p:nvGrpSpPr>
+        <p:cNvPr id="1" name=""/>
+        <p:cNvGrpSpPr/>
+        <p:nvPr/>
+      </p:nvGrpSpPr>
+      <p:grpSpPr>
+        <a:xfrm>
+          <a:off x="0" y="0"/>
+          <a:ext cx="0" cy="0"/>
+          <a:chOff x="0" y="0"/>
+          <a:chExt cx="0" cy="0"/>
+        </a:xfrm>
+      </p:grpSpPr>
+      <p:sp>
+        <p:nvSpPr>
+          <p:cNvPr id="2" name="Slide Image Placeholder 1"/>
+          <p:cNvSpPr>
+            <a:spLocks noGrp="1"/>
+          </p:cNvSpPr>
+          <p:nvPr>
+            <p:ph type="sldImg" idx="2"/>
+          </p:nvPr>
+        </p:nvSpPr>
+        <p:spPr/>
+      </p:sp>
+      <p:sp>
+        <p:nvSpPr>
+          <p:cNvPr id="3" name="Notes Placeholder 2"/>
+          <p:cNvSpPr>
+            <a:spLocks noGrp="1"/>
+          </p:cNvSpPr>
+          <p:nvPr>
+            <p:ph type="body" idx="3" sz="quarter"/>
+          </p:nvPr>
+        </p:nvSpPr>
+        <p:spPr/>
+        <p:txBody>
+          <a:bodyPr/>
+          <a:lstStyle/>
+          <a:p>
+            <a:r>
+              <a:t>ATISHAY.</a:t>
+            </a:r>
+          </a:p>
+          <a:p>
+            <a:r>
+              <a:t>All nine failure modes, evaluated at the real 50 kN, not the design load.</a:t>
+            </a:r>
+          </a:p>
+          <a:p>
+            <a:r>
+              <a:t>Nine of nine are satisfied. The busiest is shear of the eye at 76 percent of its allowable.</a:t>
+            </a:r>
+          </a:p>
+          <a:p>
+            <a:r>
+              <a:t>The point to make: none of this is stored. Ask for 80 kN and every number in this table changes</a:t>
+            </a:r>
+          </a:p>
+          <a:p>
+            <a:r>
+              <a:t>and the pin is re-sized. It is not a library of readymade models.</a:t>
+            </a:r>
+          </a:p>
+        </p:txBody>
+      </p:sp>
+      <p:sp>
+        <p:nvSpPr>
+          <p:cNvPr id="4" name="Slide Number Placeholder 3"/>
+          <p:cNvSpPr>
+            <a:spLocks noGrp="1"/>
+          </p:cNvSpPr>
+          <p:nvPr>
+            <p:ph type="sldNum" idx="5" sz="quarter"/>
+          </p:nvPr>
+        </p:nvSpPr>
+        <p:spPr/>
+      </p:sp>
+    </p:spTree>
+  </p:cSld>
+  <p:clrMapOvr>
+    <a:masterClrMapping/>
+  </p:clrMapOvr>
+</p:notes>
+</file>
+
+<file path=ppt/notesSlides/notesSlide14.xml><?xml version="1.0" encoding="utf-8"?>
+<p:notes xmlns:a="http://schemas.openxmlformats.org/drawingml/2006/main" xmlns:p="http://schemas.openxmlformats.org/presentationml/2006/main" xmlns:r="http://schemas.openxmlformats.org/officeDocument/2006/relationships">
+  <p:cSld>
+    <p:spTree>
+      <p:nvGrpSpPr>
+        <p:cNvPr id="1" name=""/>
+        <p:cNvGrpSpPr/>
+        <p:nvPr/>
+      </p:nvGrpSpPr>
+      <p:grpSpPr>
+        <a:xfrm>
+          <a:off x="0" y="0"/>
+          <a:ext cx="0" cy="0"/>
+          <a:chOff x="0" y="0"/>
+          <a:chExt cx="0" cy="0"/>
+        </a:xfrm>
+      </p:grpSpPr>
+      <p:sp>
+        <p:nvSpPr>
+          <p:cNvPr id="2" name="Slide Image Placeholder 1"/>
+          <p:cNvSpPr>
+            <a:spLocks noGrp="1"/>
+          </p:cNvSpPr>
+          <p:nvPr>
+            <p:ph type="sldImg" idx="2"/>
+          </p:nvPr>
+        </p:nvSpPr>
+        <p:spPr/>
+      </p:sp>
+      <p:sp>
+        <p:nvSpPr>
+          <p:cNvPr id="3" name="Notes Placeholder 2"/>
+          <p:cNvSpPr>
+            <a:spLocks noGrp="1"/>
+          </p:cNvSpPr>
+          <p:nvPr>
+            <p:ph type="body" idx="3" sz="quarter"/>
+          </p:nvPr>
+        </p:nvSpPr>
+        <p:spPr/>
+        <p:txBody>
+          <a:bodyPr/>
+          <a:lstStyle/>
+          <a:p>
+            <a:r>
+              <a:t>ATISHAY.</a:t>
+            </a:r>
+          </a:p>
+          <a:p>
+            <a:r>
+              <a:t>Every run prints its working: the values before rounding, the size adopted, the rule and the</a:t>
+            </a:r>
+          </a:p>
+          <a:p>
+            <a:r>
+              <a:t>source behind each proportion, every check with the numbers substituted, and the mass of each</a:t>
+            </a:r>
+          </a:p>
+          <a:p>
+            <a:r>
+              <a:t>part.</a:t>
+            </a:r>
+          </a:p>
+          <a:p>
+            <a:r>
+              <a:t>Why that matters: a reviewer does not have to trust the result. Any line can be recomputed by</a:t>
+            </a:r>
+          </a:p>
+          <a:p>
+            <a:r>
+              <a:t>hand from the formula printed next to it.</a:t>
+            </a:r>
+          </a:p>
+          <a:p>
+            <a:r>
+              <a:t>It is also the reason the findings later in this deck exist. Printing every check is what made</a:t>
+            </a:r>
+          </a:p>
+          <a:p>
+            <a:r>
+              <a:t>the errors in the books visible.</a:t>
+            </a:r>
+          </a:p>
+        </p:txBody>
+      </p:sp>
+      <p:sp>
+        <p:nvSpPr>
+          <p:cNvPr id="4" name="Slide Number Placeholder 3"/>
+          <p:cNvSpPr>
+            <a:spLocks noGrp="1"/>
+          </p:cNvSpPr>
+          <p:nvPr>
+            <p:ph type="sldNum" idx="5" sz="quarter"/>
+          </p:nvPr>
+        </p:nvSpPr>
+        <p:spPr/>
+      </p:sp>
+    </p:spTree>
+  </p:cSld>
+  <p:clrMapOvr>
+    <a:masterClrMapping/>
+  </p:clrMapOvr>
+</p:notes>
+</file>
+
+<file path=ppt/notesSlides/notesSlide15.xml><?xml version="1.0" encoding="utf-8"?>
+<p:notes xmlns:a="http://schemas.openxmlformats.org/drawingml/2006/main" xmlns:p="http://schemas.openxmlformats.org/presentationml/2006/main" xmlns:r="http://schemas.openxmlformats.org/officeDocument/2006/relationships">
+  <p:cSld>
+    <p:spTree>
+      <p:nvGrpSpPr>
+        <p:cNvPr id="1" name=""/>
+        <p:cNvGrpSpPr/>
+        <p:nvPr/>
+      </p:nvGrpSpPr>
+      <p:grpSpPr>
+        <a:xfrm>
+          <a:off x="0" y="0"/>
+          <a:ext cx="0" cy="0"/>
+          <a:chOff x="0" y="0"/>
+          <a:chExt cx="0" cy="0"/>
+        </a:xfrm>
+      </p:grpSpPr>
+      <p:sp>
+        <p:nvSpPr>
+          <p:cNvPr id="2" name="Slide Image Placeholder 1"/>
+          <p:cNvSpPr>
+            <a:spLocks noGrp="1"/>
+          </p:cNvSpPr>
+          <p:nvPr>
+            <p:ph type="sldImg" idx="2"/>
+          </p:nvPr>
+        </p:nvSpPr>
+        <p:spPr/>
+      </p:sp>
+      <p:sp>
+        <p:nvSpPr>
+          <p:cNvPr id="3" name="Notes Placeholder 2"/>
+          <p:cNvSpPr>
+            <a:spLocks noGrp="1"/>
+          </p:cNvSpPr>
+          <p:nvPr>
+            <p:ph type="body" idx="3" sz="quarter"/>
+          </p:nvPr>
+        </p:nvSpPr>
+        <p:spPr/>
+        <p:txBody>
+          <a:bodyPr/>
+          <a:lstStyle/>
+          <a:p>
+            <a:r>
+              <a:t>ATISHAY. Section opener. Say: and this is what comes out of it.</a:t>
+            </a:r>
+          </a:p>
+        </p:txBody>
+      </p:sp>
+      <p:sp>
+        <p:nvSpPr>
+          <p:cNvPr id="4" name="Slide Number Placeholder 3"/>
+          <p:cNvSpPr>
+            <a:spLocks noGrp="1"/>
+          </p:cNvSpPr>
+          <p:nvPr>
+            <p:ph type="sldNum" idx="5" sz="quarter"/>
+          </p:nvPr>
+        </p:nvSpPr>
+        <p:spPr/>
+      </p:sp>
+    </p:spTree>
+  </p:cSld>
+  <p:clrMapOvr>
+    <a:masterClrMapping/>
+  </p:clrMapOvr>
+</p:notes>
+</file>
+
+<file path=ppt/notesSlides/notesSlide16.xml><?xml version="1.0" encoding="utf-8"?>
+<p:notes xmlns:a="http://schemas.openxmlformats.org/drawingml/2006/main" xmlns:p="http://schemas.openxmlformats.org/presentationml/2006/main" xmlns:r="http://schemas.openxmlformats.org/officeDocument/2006/relationships">
+  <p:cSld>
+    <p:spTree>
+      <p:nvGrpSpPr>
+        <p:cNvPr id="1" name=""/>
+        <p:cNvGrpSpPr/>
+        <p:nvPr/>
+      </p:nvGrpSpPr>
+      <p:grpSpPr>
+        <a:xfrm>
+          <a:off x="0" y="0"/>
+          <a:ext cx="0" cy="0"/>
+          <a:chOff x="0" y="0"/>
+          <a:chExt cx="0" cy="0"/>
+        </a:xfrm>
+      </p:grpSpPr>
+      <p:sp>
+        <p:nvSpPr>
+          <p:cNvPr id="2" name="Slide Image Placeholder 1"/>
+          <p:cNvSpPr>
+            <a:spLocks noGrp="1"/>
+          </p:cNvSpPr>
+          <p:nvPr>
+            <p:ph type="sldImg" idx="2"/>
+          </p:nvPr>
+        </p:nvSpPr>
+        <p:spPr/>
+      </p:sp>
+      <p:sp>
+        <p:nvSpPr>
+          <p:cNvPr id="3" name="Notes Placeholder 2"/>
+          <p:cNvSpPr>
+            <a:spLocks noGrp="1"/>
+          </p:cNvSpPr>
+          <p:nvPr>
+            <p:ph type="body" idx="3" sz="quarter"/>
+          </p:nvPr>
+        </p:nvSpPr>
+        <p:spPr/>
+        <p:txBody>
+          <a:bodyPr/>
+          <a:lstStyle/>
+          <a:p>
+            <a:r>
+              <a:t>ATISHAY.</a:t>
+            </a:r>
+          </a:p>
+          <a:p>
+            <a:r>
+              <a:t>A first angle A3 sheet with front view, side view, plan, an isometric, dimension lines and a</a:t>
+            </a:r>
+          </a:p>
+          <a:p>
+            <a:r>
+              <a:t>title block. Produced by driving FreeCAD without opening its interface.</a:t>
+            </a:r>
+          </a:p>
+          <a:p>
+            <a:r>
+              <a:t>Alongside it: a STEP file for every part and one for the assembly, which opens in NX,</a:t>
+            </a:r>
+          </a:p>
+          <a:p>
+            <a:r>
+              <a:t>SolidWorks, Fusion and Onshape, a DXF for AutoCAD, and an editable FreeCAD file.</a:t>
+            </a:r>
+          </a:p>
+          <a:p>
+            <a:r>
+              <a:t>STEP is a neutral format, so the output is not locked to our software.</a:t>
+            </a:r>
+          </a:p>
+        </p:txBody>
+      </p:sp>
+      <p:sp>
+        <p:nvSpPr>
+          <p:cNvPr id="4" name="Slide Number Placeholder 3"/>
+          <p:cNvSpPr>
+            <a:spLocks noGrp="1"/>
+          </p:cNvSpPr>
+          <p:nvPr>
+            <p:ph type="sldNum" idx="5" sz="quarter"/>
+          </p:nvPr>
+        </p:nvSpPr>
+        <p:spPr/>
+      </p:sp>
+    </p:spTree>
+  </p:cSld>
+  <p:clrMapOvr>
+    <a:masterClrMapping/>
+  </p:clrMapOvr>
+</p:notes>
+</file>
+
+<file path=ppt/notesSlides/notesSlide17.xml><?xml version="1.0" encoding="utf-8"?>
+<p:notes xmlns:a="http://schemas.openxmlformats.org/drawingml/2006/main" xmlns:p="http://schemas.openxmlformats.org/presentationml/2006/main" xmlns:r="http://schemas.openxmlformats.org/officeDocument/2006/relationships">
+  <p:cSld>
+    <p:spTree>
+      <p:nvGrpSpPr>
+        <p:cNvPr id="1" name=""/>
+        <p:cNvGrpSpPr/>
+        <p:nvPr/>
+      </p:nvGrpSpPr>
+      <p:grpSpPr>
+        <a:xfrm>
+          <a:off x="0" y="0"/>
+          <a:ext cx="0" cy="0"/>
+          <a:chOff x="0" y="0"/>
+          <a:chExt cx="0" cy="0"/>
+        </a:xfrm>
+      </p:grpSpPr>
+      <p:sp>
+        <p:nvSpPr>
+          <p:cNvPr id="2" name="Slide Image Placeholder 1"/>
+          <p:cNvSpPr>
+            <a:spLocks noGrp="1"/>
+          </p:cNvSpPr>
+          <p:nvPr>
+            <p:ph type="sldImg" idx="2"/>
+          </p:nvPr>
+        </p:nvSpPr>
+        <p:spPr/>
+      </p:sp>
+      <p:sp>
+        <p:nvSpPr>
+          <p:cNvPr id="3" name="Notes Placeholder 2"/>
+          <p:cNvSpPr>
+            <a:spLocks noGrp="1"/>
+          </p:cNvSpPr>
+          <p:nvPr>
+            <p:ph type="body" idx="3" sz="quarter"/>
+          </p:nvPr>
+        </p:nvSpPr>
+        <p:spPr/>
+        <p:txBody>
+          <a:bodyPr/>
+          <a:lstStyle/>
+          <a:p>
+            <a:r>
+              <a:t>ATISHAY.</a:t>
+            </a:r>
+          </a:p>
+          <a:p>
+            <a:r>
+              <a:t>The assembled model, which rotates in the browser, and the same joint coloured by how close each</a:t>
+            </a:r>
+          </a:p>
+          <a:p>
+            <a:r>
+              <a:t>part is to its limit.</a:t>
+            </a:r>
+          </a:p>
+          <a:p>
+            <a:r>
+              <a:t>The colouring is useful because it puts the weakest member in front of you without reading a</a:t>
+            </a:r>
+          </a:p>
+          <a:p>
+            <a:r>
+              <a:t>table.</a:t>
+            </a:r>
+          </a:p>
+        </p:txBody>
+      </p:sp>
+      <p:sp>
+        <p:nvSpPr>
+          <p:cNvPr id="4" name="Slide Number Placeholder 3"/>
+          <p:cNvSpPr>
+            <a:spLocks noGrp="1"/>
+          </p:cNvSpPr>
+          <p:nvPr>
+            <p:ph type="sldNum" idx="5" sz="quarter"/>
+          </p:nvPr>
+        </p:nvSpPr>
+        <p:spPr/>
+      </p:sp>
+    </p:spTree>
+  </p:cSld>
+  <p:clrMapOvr>
+    <a:masterClrMapping/>
+  </p:clrMapOvr>
+</p:notes>
+</file>
+
+<file path=ppt/notesSlides/notesSlide18.xml><?xml version="1.0" encoding="utf-8"?>
+<p:notes xmlns:a="http://schemas.openxmlformats.org/drawingml/2006/main" xmlns:p="http://schemas.openxmlformats.org/presentationml/2006/main" xmlns:r="http://schemas.openxmlformats.org/officeDocument/2006/relationships">
+  <p:cSld>
+    <p:spTree>
+      <p:nvGrpSpPr>
+        <p:cNvPr id="1" name=""/>
+        <p:cNvGrpSpPr/>
+        <p:nvPr/>
+      </p:nvGrpSpPr>
+      <p:grpSpPr>
+        <a:xfrm>
+          <a:off x="0" y="0"/>
+          <a:ext cx="0" cy="0"/>
+          <a:chOff x="0" y="0"/>
+          <a:chExt cx="0" cy="0"/>
+        </a:xfrm>
+      </p:grpSpPr>
+      <p:sp>
+        <p:nvSpPr>
+          <p:cNvPr id="2" name="Slide Image Placeholder 1"/>
+          <p:cNvSpPr>
+            <a:spLocks noGrp="1"/>
+          </p:cNvSpPr>
+          <p:nvPr>
+            <p:ph type="sldImg" idx="2"/>
+          </p:nvPr>
+        </p:nvSpPr>
+        <p:spPr/>
+      </p:sp>
+      <p:sp>
+        <p:nvSpPr>
+          <p:cNvPr id="3" name="Notes Placeholder 2"/>
+          <p:cNvSpPr>
+            <a:spLocks noGrp="1"/>
+          </p:cNvSpPr>
+          <p:nvPr>
+            <p:ph type="body" idx="3" sz="quarter"/>
+          </p:nvPr>
+        </p:nvSpPr>
+        <p:spPr/>
+        <p:txBody>
+          <a:bodyPr/>
+          <a:lstStyle/>
+          <a:p>
+            <a:r>
+              <a:t>DHARMENDRA. Section opener. Say: now, how do we know any of this is correct.</a:t>
+            </a:r>
+          </a:p>
+        </p:txBody>
+      </p:sp>
+      <p:sp>
+        <p:nvSpPr>
+          <p:cNvPr id="4" name="Slide Number Placeholder 3"/>
+          <p:cNvSpPr>
+            <a:spLocks noGrp="1"/>
+          </p:cNvSpPr>
+          <p:nvPr>
+            <p:ph type="sldNum" idx="5" sz="quarter"/>
+          </p:nvPr>
+        </p:nvSpPr>
+        <p:spPr/>
+      </p:sp>
+    </p:spTree>
+  </p:cSld>
+  <p:clrMapOvr>
+    <a:masterClrMapping/>
+  </p:clrMapOvr>
+</p:notes>
+</file>
+
+<file path=ppt/notesSlides/notesSlide19.xml><?xml version="1.0" encoding="utf-8"?>
+<p:notes xmlns:a="http://schemas.openxmlformats.org/drawingml/2006/main" xmlns:p="http://schemas.openxmlformats.org/presentationml/2006/main" xmlns:r="http://schemas.openxmlformats.org/officeDocument/2006/relationships">
+  <p:cSld>
+    <p:spTree>
+      <p:nvGrpSpPr>
+        <p:cNvPr id="1" name=""/>
+        <p:cNvGrpSpPr/>
+        <p:nvPr/>
+      </p:nvGrpSpPr>
+      <p:grpSpPr>
+        <a:xfrm>
+          <a:off x="0" y="0"/>
+          <a:ext cx="0" cy="0"/>
+          <a:chOff x="0" y="0"/>
+          <a:chExt cx="0" cy="0"/>
+        </a:xfrm>
+      </p:grpSpPr>
+      <p:sp>
+        <p:nvSpPr>
+          <p:cNvPr id="2" name="Slide Image Placeholder 1"/>
+          <p:cNvSpPr>
+            <a:spLocks noGrp="1"/>
+          </p:cNvSpPr>
+          <p:nvPr>
+            <p:ph type="sldImg" idx="2"/>
+          </p:nvPr>
+        </p:nvSpPr>
+        <p:spPr/>
+      </p:sp>
+      <p:sp>
+        <p:nvSpPr>
+          <p:cNvPr id="3" name="Notes Placeholder 2"/>
+          <p:cNvSpPr>
+            <a:spLocks noGrp="1"/>
+          </p:cNvSpPr>
+          <p:nvPr>
+            <p:ph type="body" idx="3" sz="quarter"/>
+          </p:nvPr>
+        </p:nvSpPr>
+        <p:spPr/>
+        <p:txBody>
+          <a:bodyPr/>
+          <a:lstStyle/>
+          <a:p>
+            <a:r>
+              <a:t>DHARMENDRA.</a:t>
+            </a:r>
+          </a:p>
+          <a:p>
+            <a:r>
+              <a:t>Every proportion and every check was compared against the three sources.</a:t>
+            </a:r>
+          </a:p>
+          <a:p>
+            <a:r>
+              <a:t>Knuckle and cotter are fully verified. The cotter joint is verified twice over, against two</a:t>
+            </a:r>
+          </a:p>
+          <a:p>
+            <a:r>
+              <a:t>independent books.</a:t>
+            </a:r>
+          </a:p>
+          <a:p>
+            <a:r>
+              <a:t>Two entries are honest limitations rather than gaps. For the flange coupling all seven checks</a:t>
+            </a:r>
+          </a:p>
+          <a:p>
+            <a:r>
+              <a:t>are verified twice, but the proportions cannot be verified, because Leutwiler records that no</a:t>
+            </a:r>
+          </a:p>
+          <a:p>
+            <a:r>
+              <a:t>standard set of flange coupling proportions was ever agreed and that published tables are</a:t>
+            </a:r>
+          </a:p>
+          <a:p>
+            <a:r>
+              <a:t>individual manufacturers' practice. For the sleeve and cotter joint we searched four books and</a:t>
+            </a:r>
+          </a:p>
+          <a:p>
+            <a:r>
+              <a:t>none covers it by name.</a:t>
+            </a:r>
+          </a:p>
+          <a:p>
+            <a:r>
+              <a:t>Where no source exists, the software says so on every single run rather than implying one.</a:t>
+            </a:r>
+          </a:p>
+        </p:txBody>
+      </p:sp>
+      <p:sp>
+        <p:nvSpPr>
+          <p:cNvPr id="4" name="Slide Number Placeholder 3"/>
+          <p:cNvSpPr>
+            <a:spLocks noGrp="1"/>
+          </p:cNvSpPr>
+          <p:nvPr>
+            <p:ph type="sldNum" idx="5" sz="quarter"/>
+          </p:nvPr>
+        </p:nvSpPr>
+        <p:spPr/>
+      </p:sp>
+    </p:spTree>
+  </p:cSld>
+  <p:clrMapOvr>
+    <a:masterClrMapping/>
+  </p:clrMapOvr>
+</p:notes>
+</file>
+
+<file path=ppt/notesSlides/notesSlide2.xml><?xml version="1.0" encoding="utf-8"?>
+<p:notes xmlns:a="http://schemas.openxmlformats.org/drawingml/2006/main" xmlns:p="http://schemas.openxmlformats.org/presentationml/2006/main" xmlns:r="http://schemas.openxmlformats.org/officeDocument/2006/relationships">
+  <p:cSld>
+    <p:spTree>
+      <p:nvGrpSpPr>
+        <p:cNvPr id="1" name=""/>
+        <p:cNvGrpSpPr/>
+        <p:nvPr/>
+      </p:nvGrpSpPr>
+      <p:grpSpPr>
+        <a:xfrm>
+          <a:off x="0" y="0"/>
+          <a:ext cx="0" cy="0"/>
+          <a:chOff x="0" y="0"/>
+          <a:chExt cx="0" cy="0"/>
+        </a:xfrm>
+      </p:grpSpPr>
+      <p:sp>
+        <p:nvSpPr>
+          <p:cNvPr id="2" name="Slide Image Placeholder 1"/>
+          <p:cNvSpPr>
+            <a:spLocks noGrp="1"/>
+          </p:cNvSpPr>
+          <p:nvPr>
+            <p:ph type="sldImg" idx="2"/>
+          </p:nvPr>
+        </p:nvSpPr>
+        <p:spPr/>
+      </p:sp>
+      <p:sp>
+        <p:nvSpPr>
+          <p:cNvPr id="3" name="Notes Placeholder 2"/>
+          <p:cNvSpPr>
+            <a:spLocks noGrp="1"/>
+          </p:cNvSpPr>
+          <p:nvPr>
+            <p:ph type="body" idx="3" sz="quarter"/>
+          </p:nvPr>
+        </p:nvSpPr>
+        <p:spPr/>
+        <p:txBody>
+          <a:bodyPr/>
+          <a:lstStyle/>
+          <a:p>
+            <a:r>
+              <a:t>ANSH. Section opener. Say only: first, why this problem is worth solving at all.</a:t>
+            </a:r>
+          </a:p>
+        </p:txBody>
+      </p:sp>
+      <p:sp>
+        <p:nvSpPr>
+          <p:cNvPr id="4" name="Slide Number Placeholder 3"/>
+          <p:cNvSpPr>
+            <a:spLocks noGrp="1"/>
+          </p:cNvSpPr>
+          <p:nvPr>
+            <p:ph type="sldNum" idx="5" sz="quarter"/>
+          </p:nvPr>
+        </p:nvSpPr>
+        <p:spPr/>
+      </p:sp>
+    </p:spTree>
+  </p:cSld>
+  <p:clrMapOvr>
+    <a:masterClrMapping/>
+  </p:clrMapOvr>
+</p:notes>
+</file>
+
+<file path=ppt/notesSlides/notesSlide20.xml><?xml version="1.0" encoding="utf-8"?>
+<p:notes xmlns:a="http://schemas.openxmlformats.org/drawingml/2006/main" xmlns:p="http://schemas.openxmlformats.org/presentationml/2006/main" xmlns:r="http://schemas.openxmlformats.org/officeDocument/2006/relationships">
+  <p:cSld>
+    <p:spTree>
+      <p:nvGrpSpPr>
+        <p:cNvPr id="1" name=""/>
+        <p:cNvGrpSpPr/>
+        <p:nvPr/>
+      </p:nvGrpSpPr>
+      <p:grpSpPr>
+        <a:xfrm>
+          <a:off x="0" y="0"/>
+          <a:ext cx="0" cy="0"/>
+          <a:chOff x="0" y="0"/>
+          <a:chExt cx="0" cy="0"/>
+        </a:xfrm>
+      </p:grpSpPr>
+      <p:sp>
+        <p:nvSpPr>
+          <p:cNvPr id="2" name="Slide Image Placeholder 1"/>
+          <p:cNvSpPr>
+            <a:spLocks noGrp="1"/>
+          </p:cNvSpPr>
+          <p:nvPr>
+            <p:ph type="sldImg" idx="2"/>
+          </p:nvPr>
+        </p:nvSpPr>
+        <p:spPr/>
+      </p:sp>
+      <p:sp>
+        <p:nvSpPr>
+          <p:cNvPr id="3" name="Notes Placeholder 2"/>
+          <p:cNvSpPr>
+            <a:spLocks noGrp="1"/>
+          </p:cNvSpPr>
+          <p:nvPr>
+            <p:ph type="body" idx="3" sz="quarter"/>
+          </p:nvPr>
+        </p:nvSpPr>
+        <p:spPr/>
+        <p:txBody>
+          <a:bodyPr/>
+          <a:lstStyle/>
+          <a:p>
+            <a:r>
+              <a:t>DHARMENDRA.</a:t>
+            </a:r>
+          </a:p>
+          <a:p>
+            <a:r>
+              <a:t>The first of three errors we found in the published sources.</a:t>
+            </a:r>
+          </a:p>
+          <a:p>
+            <a:r>
+              <a:t>The knuckle worked problem raises the pin from 40 to 55 millimetres to satisfy bending, then</a:t>
+            </a:r>
+          </a:p>
+          <a:p>
+            <a:r>
+              <a:t>checks the eye using the original 40 millimetre pin.</a:t>
+            </a:r>
+          </a:p>
+          <a:p>
+            <a:r>
+              <a:t>Put the pin it actually adopted into its own expression and you get 80 MPa against an allowable</a:t>
+            </a:r>
+          </a:p>
+          <a:p>
+            <a:r>
+              <a:t>of 65. Its own answer fails its own check by 23 percent.</a:t>
+            </a:r>
+          </a:p>
+          <a:p>
+            <a:r>
+              <a:t>Our software instead enlarges the outer diameter of the eye until the check passes, and reports</a:t>
+            </a:r>
+          </a:p>
+          <a:p>
+            <a:r>
+              <a:t>that it has done so.</a:t>
+            </a:r>
+          </a:p>
+        </p:txBody>
+      </p:sp>
+      <p:sp>
+        <p:nvSpPr>
+          <p:cNvPr id="4" name="Slide Number Placeholder 3"/>
+          <p:cNvSpPr>
+            <a:spLocks noGrp="1"/>
+          </p:cNvSpPr>
+          <p:nvPr>
+            <p:ph type="sldNum" idx="5" sz="quarter"/>
+          </p:nvPr>
+        </p:nvSpPr>
+        <p:spPr/>
+      </p:sp>
+    </p:spTree>
+  </p:cSld>
+  <p:clrMapOvr>
+    <a:masterClrMapping/>
+  </p:clrMapOvr>
+</p:notes>
+</file>
+
+<file path=ppt/notesSlides/notesSlide21.xml><?xml version="1.0" encoding="utf-8"?>
+<p:notes xmlns:a="http://schemas.openxmlformats.org/drawingml/2006/main" xmlns:p="http://schemas.openxmlformats.org/presentationml/2006/main" xmlns:r="http://schemas.openxmlformats.org/officeDocument/2006/relationships">
+  <p:cSld>
+    <p:spTree>
+      <p:nvGrpSpPr>
+        <p:cNvPr id="1" name=""/>
+        <p:cNvGrpSpPr/>
+        <p:nvPr/>
+      </p:nvGrpSpPr>
+      <p:grpSpPr>
+        <a:xfrm>
+          <a:off x="0" y="0"/>
+          <a:ext cx="0" cy="0"/>
+          <a:chOff x="0" y="0"/>
+          <a:chExt cx="0" cy="0"/>
+        </a:xfrm>
+      </p:grpSpPr>
+      <p:sp>
+        <p:nvSpPr>
+          <p:cNvPr id="2" name="Slide Image Placeholder 1"/>
+          <p:cNvSpPr>
+            <a:spLocks noGrp="1"/>
+          </p:cNvSpPr>
+          <p:nvPr>
+            <p:ph type="sldImg" idx="2"/>
+          </p:nvPr>
+        </p:nvSpPr>
+        <p:spPr/>
+      </p:sp>
+      <p:sp>
+        <p:nvSpPr>
+          <p:cNvPr id="3" name="Notes Placeholder 2"/>
+          <p:cNvSpPr>
+            <a:spLocks noGrp="1"/>
+          </p:cNvSpPr>
+          <p:nvPr>
+            <p:ph type="body" idx="3" sz="quarter"/>
+          </p:nvPr>
+        </p:nvSpPr>
+        <p:spPr/>
+        <p:txBody>
+          <a:bodyPr/>
+          <a:lstStyle/>
+          <a:p>
+            <a:r>
+              <a:t>DHARMENDRA.</a:t>
+            </a:r>
+          </a:p>
+          <a:p>
+            <a:r>
+              <a:t>Two more.</a:t>
+            </a:r>
+          </a:p>
+          <a:p>
+            <a:r>
+              <a:t>The cotter procedure checks crushing of the socket but never crushing between the cotter and the</a:t>
+            </a:r>
+          </a:p>
+          <a:p>
+            <a:r>
+              <a:t>spigot. At its own final answer that omitted check reads 167 MPa against 110 allowed. Leutwiler</a:t>
+            </a:r>
+          </a:p>
+          <a:p>
+            <a:r>
+              <a:t>lists it as one of ten failure modes, which is what makes it an omission and not a preference.</a:t>
+            </a:r>
+          </a:p>
+          <a:p>
+            <a:r>
+              <a:t>Second, the bolt tightening constant is printed as 284 d kilonewtons, but the worked example on</a:t>
+            </a:r>
+          </a:p>
+          <a:p>
+            <a:r>
+              <a:t>the same page gives 56.8 kN for an M20 bolt. That only works if the constant is 2840 d newtons.</a:t>
+            </a:r>
+          </a:p>
+          <a:p>
+            <a:r>
+              <a:t>The page refutes itself, and it is out by a factor of ten.</a:t>
+            </a:r>
+          </a:p>
+          <a:p>
+            <a:r>
+              <a:t>We found none of these by reading. We found them because the software computes every check and</a:t>
+            </a:r>
+          </a:p>
+          <a:p>
+            <a:r>
+              <a:t>prints the arithmetic.</a:t>
+            </a:r>
+          </a:p>
+        </p:txBody>
+      </p:sp>
+      <p:sp>
+        <p:nvSpPr>
+          <p:cNvPr id="4" name="Slide Number Placeholder 3"/>
+          <p:cNvSpPr>
+            <a:spLocks noGrp="1"/>
+          </p:cNvSpPr>
+          <p:nvPr>
+            <p:ph type="sldNum" idx="5" sz="quarter"/>
+          </p:nvPr>
+        </p:nvSpPr>
+        <p:spPr/>
+      </p:sp>
+    </p:spTree>
+  </p:cSld>
+  <p:clrMapOvr>
+    <a:masterClrMapping/>
+  </p:clrMapOvr>
+</p:notes>
+</file>
+
+<file path=ppt/notesSlides/notesSlide22.xml><?xml version="1.0" encoding="utf-8"?>
+<p:notes xmlns:a="http://schemas.openxmlformats.org/drawingml/2006/main" xmlns:p="http://schemas.openxmlformats.org/presentationml/2006/main" xmlns:r="http://schemas.openxmlformats.org/officeDocument/2006/relationships">
+  <p:cSld>
+    <p:spTree>
+      <p:nvGrpSpPr>
+        <p:cNvPr id="1" name=""/>
+        <p:cNvGrpSpPr/>
+        <p:nvPr/>
+      </p:nvGrpSpPr>
+      <p:grpSpPr>
+        <a:xfrm>
+          <a:off x="0" y="0"/>
+          <a:ext cx="0" cy="0"/>
+          <a:chOff x="0" y="0"/>
+          <a:chExt cx="0" cy="0"/>
+        </a:xfrm>
+      </p:grpSpPr>
+      <p:sp>
+        <p:nvSpPr>
+          <p:cNvPr id="2" name="Slide Image Placeholder 1"/>
+          <p:cNvSpPr>
+            <a:spLocks noGrp="1"/>
+          </p:cNvSpPr>
+          <p:nvPr>
+            <p:ph type="sldImg" idx="2"/>
+          </p:nvPr>
+        </p:nvSpPr>
+        <p:spPr/>
+      </p:sp>
+      <p:sp>
+        <p:nvSpPr>
+          <p:cNvPr id="3" name="Notes Placeholder 2"/>
+          <p:cNvSpPr>
+            <a:spLocks noGrp="1"/>
+          </p:cNvSpPr>
+          <p:nvPr>
+            <p:ph type="body" idx="3" sz="quarter"/>
+          </p:nvPr>
+        </p:nvSpPr>
+        <p:spPr/>
+        <p:txBody>
+          <a:bodyPr/>
+          <a:lstStyle/>
+          <a:p>
+            <a:r>
+              <a:t>ANKUR. Section opener. Say: finally, how the work is validated and what it does not do.</a:t>
+            </a:r>
+          </a:p>
+        </p:txBody>
+      </p:sp>
+      <p:sp>
+        <p:nvSpPr>
+          <p:cNvPr id="4" name="Slide Number Placeholder 3"/>
+          <p:cNvSpPr>
+            <a:spLocks noGrp="1"/>
+          </p:cNvSpPr>
+          <p:nvPr>
+            <p:ph type="sldNum" idx="5" sz="quarter"/>
+          </p:nvPr>
+        </p:nvSpPr>
+        <p:spPr/>
+      </p:sp>
+    </p:spTree>
+  </p:cSld>
+  <p:clrMapOvr>
+    <a:masterClrMapping/>
+  </p:clrMapOvr>
+</p:notes>
+</file>
+
+<file path=ppt/notesSlides/notesSlide23.xml><?xml version="1.0" encoding="utf-8"?>
+<p:notes xmlns:a="http://schemas.openxmlformats.org/drawingml/2006/main" xmlns:p="http://schemas.openxmlformats.org/presentationml/2006/main" xmlns:r="http://schemas.openxmlformats.org/officeDocument/2006/relationships">
+  <p:cSld>
+    <p:spTree>
+      <p:nvGrpSpPr>
+        <p:cNvPr id="1" name=""/>
+        <p:cNvGrpSpPr/>
+        <p:nvPr/>
+      </p:nvGrpSpPr>
+      <p:grpSpPr>
+        <a:xfrm>
+          <a:off x="0" y="0"/>
+          <a:ext cx="0" cy="0"/>
+          <a:chOff x="0" y="0"/>
+          <a:chExt cx="0" cy="0"/>
+        </a:xfrm>
+      </p:grpSpPr>
+      <p:sp>
+        <p:nvSpPr>
+          <p:cNvPr id="2" name="Slide Image Placeholder 1"/>
+          <p:cNvSpPr>
+            <a:spLocks noGrp="1"/>
+          </p:cNvSpPr>
+          <p:nvPr>
+            <p:ph type="sldImg" idx="2"/>
+          </p:nvPr>
+        </p:nvSpPr>
+        <p:spPr/>
+      </p:sp>
+      <p:sp>
+        <p:nvSpPr>
+          <p:cNvPr id="3" name="Notes Placeholder 2"/>
+          <p:cNvSpPr>
+            <a:spLocks noGrp="1"/>
+          </p:cNvSpPr>
+          <p:nvPr>
+            <p:ph type="body" idx="3" sz="quarter"/>
+          </p:nvPr>
+        </p:nvSpPr>
+        <p:spPr/>
+        <p:txBody>
+          <a:bodyPr/>
+          <a:lstStyle/>
+          <a:p>
+            <a:r>
+              <a:t>ANKUR.</a:t>
+            </a:r>
+          </a:p>
+          <a:p>
+            <a:r>
+              <a:t>An independent finite element cross check.</a:t>
+            </a:r>
+          </a:p>
+          <a:p>
+            <a:r>
+              <a:t>First validated on a case with a known answer: a 20 mm bar in tension, formula 31.83, computed</a:t>
+            </a:r>
+          </a:p>
+          <a:p>
+            <a:r>
+              <a:t>32.22, a difference of 1.2 percent.</a:t>
+            </a:r>
+          </a:p>
+          <a:p>
+            <a:r>
+              <a:t>On the knuckle eye rod: formula 52.0, computed 57.9, about 11.5 percent higher. That is expected,</a:t>
+            </a:r>
+          </a:p>
+          <a:p>
+            <a:r>
+              <a:t>because the formula treats the rod as a plain bar and ignores the stress raised at the pin bore.</a:t>
+            </a:r>
+          </a:p>
+          <a:p>
+            <a:r>
+              <a:t>Both stay under the 75 MPa allowable.</a:t>
+            </a:r>
+          </a:p>
+          <a:p>
+            <a:r>
+              <a:t>The important part: a peak that never settles is not a stress. On one part the computed peak</a:t>
+            </a:r>
+          </a:p>
+          <a:p>
+            <a:r>
+              <a:t>moved between 157 and 191 MPa as we refined the mesh sixteen fold. So the software re-solves on</a:t>
+            </a:r>
+          </a:p>
+          <a:p>
+            <a:r>
+              <a:t>a finer mesh and reports NOT CONVERGED when the number will not settle, and tells you to design</a:t>
+            </a:r>
+          </a:p>
+          <a:p>
+            <a:r>
+              <a:t>to the hand calculation.</a:t>
+            </a:r>
+          </a:p>
+        </p:txBody>
+      </p:sp>
+      <p:sp>
+        <p:nvSpPr>
+          <p:cNvPr id="4" name="Slide Number Placeholder 3"/>
+          <p:cNvSpPr>
+            <a:spLocks noGrp="1"/>
+          </p:cNvSpPr>
+          <p:nvPr>
+            <p:ph type="sldNum" idx="5" sz="quarter"/>
+          </p:nvPr>
+        </p:nvSpPr>
+        <p:spPr/>
+      </p:sp>
+    </p:spTree>
+  </p:cSld>
+  <p:clrMapOvr>
+    <a:masterClrMapping/>
+  </p:clrMapOvr>
+</p:notes>
+</file>
+
+<file path=ppt/notesSlides/notesSlide24.xml><?xml version="1.0" encoding="utf-8"?>
+<p:notes xmlns:a="http://schemas.openxmlformats.org/drawingml/2006/main" xmlns:p="http://schemas.openxmlformats.org/presentationml/2006/main" xmlns:r="http://schemas.openxmlformats.org/officeDocument/2006/relationships">
+  <p:cSld>
+    <p:spTree>
+      <p:nvGrpSpPr>
+        <p:cNvPr id="1" name=""/>
+        <p:cNvGrpSpPr/>
+        <p:nvPr/>
+      </p:nvGrpSpPr>
+      <p:grpSpPr>
+        <a:xfrm>
+          <a:off x="0" y="0"/>
+          <a:ext cx="0" cy="0"/>
+          <a:chOff x="0" y="0"/>
+          <a:chExt cx="0" cy="0"/>
+        </a:xfrm>
+      </p:grpSpPr>
+      <p:sp>
+        <p:nvSpPr>
+          <p:cNvPr id="2" name="Slide Image Placeholder 1"/>
+          <p:cNvSpPr>
+            <a:spLocks noGrp="1"/>
+          </p:cNvSpPr>
+          <p:nvPr>
+            <p:ph type="sldImg" idx="2"/>
+          </p:nvPr>
+        </p:nvSpPr>
+        <p:spPr/>
+      </p:sp>
+      <p:sp>
+        <p:nvSpPr>
+          <p:cNvPr id="3" name="Notes Placeholder 2"/>
+          <p:cNvSpPr>
+            <a:spLocks noGrp="1"/>
+          </p:cNvSpPr>
+          <p:nvPr>
+            <p:ph type="body" idx="3" sz="quarter"/>
+          </p:nvPr>
+        </p:nvSpPr>
+        <p:spPr/>
+        <p:txBody>
+          <a:bodyPr/>
+          <a:lstStyle/>
+          <a:p>
+            <a:r>
+              <a:t>ANKUR.</a:t>
+            </a:r>
+          </a:p>
+          <a:p>
+            <a:r>
+              <a:t>290 automated tests run on every change: the arithmetic, the geometry, the parsing, the drawing</a:t>
+            </a:r>
+          </a:p>
+          <a:p>
+            <a:r>
+              <a:t>and the analysis.</a:t>
+            </a:r>
+          </a:p>
+          <a:p>
+            <a:r>
+              <a:t>The row that matters most is the last one. There are tests that assert the three errors in the</a:t>
+            </a:r>
+          </a:p>
+          <a:p>
+            <a:r>
+              <a:t>books are real. Without them, someone could later correct our software back to the printed</a:t>
+            </a:r>
+          </a:p>
+          <a:p>
+            <a:r>
+              <a:t>answers and every other test would still pass.</a:t>
+            </a:r>
+          </a:p>
+          <a:p>
+            <a:r>
+              <a:t>One test found something no dimension check could: comparing the solids pairwise caught a gib</a:t>
+            </a:r>
+          </a:p>
+          <a:p>
+            <a:r>
+              <a:t>hook modelled 1.25 millimetres inside the strap, occupying metal another part already occupied,</a:t>
+            </a:r>
+          </a:p>
+          <a:p>
+            <a:r>
+              <a:t>while every individual dimension was correct.</a:t>
+            </a:r>
+          </a:p>
+        </p:txBody>
+      </p:sp>
+      <p:sp>
+        <p:nvSpPr>
+          <p:cNvPr id="4" name="Slide Number Placeholder 3"/>
+          <p:cNvSpPr>
+            <a:spLocks noGrp="1"/>
+          </p:cNvSpPr>
+          <p:nvPr>
+            <p:ph type="sldNum" idx="5" sz="quarter"/>
+          </p:nvPr>
+        </p:nvSpPr>
+        <p:spPr/>
+      </p:sp>
+    </p:spTree>
+  </p:cSld>
+  <p:clrMapOvr>
+    <a:masterClrMapping/>
+  </p:clrMapOvr>
+</p:notes>
+</file>
+
+<file path=ppt/notesSlides/notesSlide25.xml><?xml version="1.0" encoding="utf-8"?>
+<p:notes xmlns:a="http://schemas.openxmlformats.org/drawingml/2006/main" xmlns:p="http://schemas.openxmlformats.org/presentationml/2006/main" xmlns:r="http://schemas.openxmlformats.org/officeDocument/2006/relationships">
+  <p:cSld>
+    <p:spTree>
+      <p:nvGrpSpPr>
+        <p:cNvPr id="1" name=""/>
+        <p:cNvGrpSpPr/>
+        <p:nvPr/>
+      </p:nvGrpSpPr>
+      <p:grpSpPr>
+        <a:xfrm>
+          <a:off x="0" y="0"/>
+          <a:ext cx="0" cy="0"/>
+          <a:chOff x="0" y="0"/>
+          <a:chExt cx="0" cy="0"/>
+        </a:xfrm>
+      </p:grpSpPr>
+      <p:sp>
+        <p:nvSpPr>
+          <p:cNvPr id="2" name="Slide Image Placeholder 1"/>
+          <p:cNvSpPr>
+            <a:spLocks noGrp="1"/>
+          </p:cNvSpPr>
+          <p:nvPr>
+            <p:ph type="sldImg" idx="2"/>
+          </p:nvPr>
+        </p:nvSpPr>
+        <p:spPr/>
+      </p:sp>
+      <p:sp>
+        <p:nvSpPr>
+          <p:cNvPr id="3" name="Notes Placeholder 2"/>
+          <p:cNvSpPr>
+            <a:spLocks noGrp="1"/>
+          </p:cNvSpPr>
+          <p:nvPr>
+            <p:ph type="body" idx="3" sz="quarter"/>
+          </p:nvPr>
+        </p:nvSpPr>
+        <p:spPr/>
+        <p:txBody>
+          <a:bodyPr/>
+          <a:lstStyle/>
+          <a:p>
+            <a:r>
+              <a:t>ANKUR.</a:t>
+            </a:r>
+          </a:p>
+          <a:p>
+            <a:r>
+              <a:t>What it does not do, said before anyone asks.</a:t>
+            </a:r>
+          </a:p>
+          <a:p>
+            <a:r>
+              <a:t>Static loading only, so no fatigue and no stress concentration factors. Nominal dimensions only,</a:t>
+            </a:r>
+          </a:p>
+          <a:p>
+            <a:r>
+              <a:t>so no tolerances or fits, which means the sheet is not yet a manufacturing drawing. Two of the</a:t>
+            </a:r>
+          </a:p>
+          <a:p>
+            <a:r>
+              <a:t>six joints have proportions with no book behind them, and the software says so every run. Nut</a:t>
+            </a:r>
+          </a:p>
+          <a:p>
+            <a:r>
+              <a:t>thread stripping is not checked.</a:t>
+            </a:r>
+          </a:p>
+          <a:p>
+            <a:r>
+              <a:t>Future scope: riveted and welded joints follow the same pattern, then fatigue, then tolerances</a:t>
+            </a:r>
+          </a:p>
+          <a:p>
+            <a:r>
+              <a:t>and fits, then a journal script so the assembly builds inside NX rather than being imported.</a:t>
+            </a:r>
+          </a:p>
+        </p:txBody>
+      </p:sp>
+      <p:sp>
+        <p:nvSpPr>
+          <p:cNvPr id="4" name="Slide Number Placeholder 3"/>
+          <p:cNvSpPr>
+            <a:spLocks noGrp="1"/>
+          </p:cNvSpPr>
+          <p:nvPr>
+            <p:ph type="sldNum" idx="5" sz="quarter"/>
+          </p:nvPr>
+        </p:nvSpPr>
+        <p:spPr/>
+      </p:sp>
+    </p:spTree>
+  </p:cSld>
+  <p:clrMapOvr>
+    <a:masterClrMapping/>
+  </p:clrMapOvr>
+</p:notes>
+</file>
+
+<file path=ppt/notesSlides/notesSlide26.xml><?xml version="1.0" encoding="utf-8"?>
+<p:notes xmlns:a="http://schemas.openxmlformats.org/drawingml/2006/main" xmlns:p="http://schemas.openxmlformats.org/presentationml/2006/main" xmlns:r="http://schemas.openxmlformats.org/officeDocument/2006/relationships">
+  <p:cSld>
+    <p:spTree>
+      <p:nvGrpSpPr>
+        <p:cNvPr id="1" name=""/>
+        <p:cNvGrpSpPr/>
+        <p:nvPr/>
+      </p:nvGrpSpPr>
+      <p:grpSpPr>
+        <a:xfrm>
+          <a:off x="0" y="0"/>
+          <a:ext cx="0" cy="0"/>
+          <a:chOff x="0" y="0"/>
+          <a:chExt cx="0" cy="0"/>
+        </a:xfrm>
+      </p:grpSpPr>
+      <p:sp>
+        <p:nvSpPr>
+          <p:cNvPr id="2" name="Slide Image Placeholder 1"/>
+          <p:cNvSpPr>
+            <a:spLocks noGrp="1"/>
+          </p:cNvSpPr>
+          <p:nvPr>
+            <p:ph type="sldImg" idx="2"/>
+          </p:nvPr>
+        </p:nvSpPr>
+        <p:spPr/>
+      </p:sp>
+      <p:sp>
+        <p:nvSpPr>
+          <p:cNvPr id="3" name="Notes Placeholder 2"/>
+          <p:cNvSpPr>
+            <a:spLocks noGrp="1"/>
+          </p:cNvSpPr>
+          <p:nvPr>
+            <p:ph type="body" idx="3" sz="quarter"/>
+          </p:nvPr>
+        </p:nvSpPr>
+        <p:spPr/>
+        <p:txBody>
+          <a:bodyPr/>
+          <a:lstStyle/>
+          <a:p>
+            <a:r>
+              <a:t>ANKUR.</a:t>
+            </a:r>
+          </a:p>
+          <a:p>
+            <a:r>
+              <a:t>To close.</a:t>
+            </a:r>
+          </a:p>
+          <a:p>
+            <a:r>
+              <a:t>Every dimension this software produces can be traced to a formula, and every formula to a page</a:t>
+            </a:r>
+          </a:p>
+          <a:p>
+            <a:r>
+              <a:t>in a book. That is the difference between a tool that designs and one that only draws.</a:t>
+            </a:r>
+          </a:p>
+          <a:p>
+            <a:r>
+              <a:t>The language model reads the requirement. The engineering stays deterministic, checked, and open</a:t>
+            </a:r>
+          </a:p>
+          <a:p>
+            <a:r>
+              <a:t>to inspection.</a:t>
+            </a:r>
+          </a:p>
+          <a:p>
+            <a:r>
+              <a:t>Six joints, 44 checks, 290 tests, and three errors found in published literature along the way.</a:t>
+            </a:r>
+          </a:p>
+          <a:p>
+            <a:r>
+              <a:t>Thank you. We are happy to take questions.</a:t>
+            </a:r>
+          </a:p>
+        </p:txBody>
+      </p:sp>
+      <p:sp>
+        <p:nvSpPr>
+          <p:cNvPr id="4" name="Slide Number Placeholder 3"/>
+          <p:cNvSpPr>
+            <a:spLocks noGrp="1"/>
+          </p:cNvSpPr>
+          <p:nvPr>
+            <p:ph type="sldNum" idx="5" sz="quarter"/>
+          </p:nvPr>
+        </p:nvSpPr>
+        <p:spPr/>
+      </p:sp>
+    </p:spTree>
+  </p:cSld>
+  <p:clrMapOvr>
+    <a:masterClrMapping/>
+  </p:clrMapOvr>
+</p:notes>
+</file>
+
+<file path=ppt/notesSlides/notesSlide3.xml><?xml version="1.0" encoding="utf-8"?>
+<p:notes xmlns:a="http://schemas.openxmlformats.org/drawingml/2006/main" xmlns:p="http://schemas.openxmlformats.org/presentationml/2006/main" xmlns:r="http://schemas.openxmlformats.org/officeDocument/2006/relationships">
+  <p:cSld>
+    <p:spTree>
+      <p:nvGrpSpPr>
+        <p:cNvPr id="1" name=""/>
+        <p:cNvGrpSpPr/>
+        <p:nvPr/>
+      </p:nvGrpSpPr>
+      <p:grpSpPr>
+        <a:xfrm>
+          <a:off x="0" y="0"/>
+          <a:ext cx="0" cy="0"/>
+          <a:chOff x="0" y="0"/>
+          <a:chExt cx="0" cy="0"/>
+        </a:xfrm>
+      </p:grpSpPr>
+      <p:sp>
+        <p:nvSpPr>
+          <p:cNvPr id="2" name="Slide Image Placeholder 1"/>
+          <p:cNvSpPr>
+            <a:spLocks noGrp="1"/>
+          </p:cNvSpPr>
+          <p:nvPr>
+            <p:ph type="sldImg" idx="2"/>
+          </p:nvPr>
+        </p:nvSpPr>
+        <p:spPr/>
+      </p:sp>
+      <p:sp>
+        <p:nvSpPr>
+          <p:cNvPr id="3" name="Notes Placeholder 2"/>
+          <p:cNvSpPr>
+            <a:spLocks noGrp="1"/>
+          </p:cNvSpPr>
+          <p:nvPr>
+            <p:ph type="body" idx="3" sz="quarter"/>
+          </p:nvPr>
+        </p:nvSpPr>
+        <p:spPr/>
+        <p:txBody>
+          <a:bodyPr/>
+          <a:lstStyle/>
+          <a:p>
+            <a:r>
+              <a:t>ANSH.</a:t>
+            </a:r>
+          </a:p>
+          <a:p>
+            <a:r>
+              <a:t>Designing a standard joint is not creative work, it is a fixed recipe. For a knuckle joint you</a:t>
+            </a:r>
+          </a:p>
+          <a:p>
+            <a:r>
+              <a:t>find the rod from tension, size the pin twice, once for shear and once for bending, take the</a:t>
+            </a:r>
+          </a:p>
+          <a:p>
+            <a:r>
+              <a:t>larger, derive seven more dimensions from the rod, then check nine ways it can fail.</a:t>
+            </a:r>
+          </a:p>
+          <a:p>
+            <a:r>
+              <a:t>Change the load and you do all of it again from the start.</a:t>
+            </a:r>
+          </a:p>
+          <a:p>
+            <a:r>
+              <a:t>The thinking is five minutes. The arithmetic is the afternoon.</a:t>
+            </a:r>
+          </a:p>
+          <a:p>
+            <a:r>
+              <a:t>CAD removed the drawing work but not this. A modeller will happily draw a pin too thin to</a:t>
+            </a:r>
+          </a:p>
+          <a:p>
+            <a:r>
+              <a:t>survive, because it does not know what a pin is.</a:t>
+            </a:r>
+          </a:p>
+          <a:p>
+            <a:r>
+              <a:t>Our aim: keep every formula exactly as the textbook has it, and remove only the repetition.</a:t>
+            </a:r>
+          </a:p>
+        </p:txBody>
+      </p:sp>
+      <p:sp>
+        <p:nvSpPr>
+          <p:cNvPr id="4" name="Slide Number Placeholder 3"/>
+          <p:cNvSpPr>
+            <a:spLocks noGrp="1"/>
+          </p:cNvSpPr>
+          <p:nvPr>
+            <p:ph type="sldNum" idx="5" sz="quarter"/>
+          </p:nvPr>
+        </p:nvSpPr>
+        <p:spPr/>
+      </p:sp>
+    </p:spTree>
+  </p:cSld>
+  <p:clrMapOvr>
+    <a:masterClrMapping/>
+  </p:clrMapOvr>
+</p:notes>
+</file>
+
+<file path=ppt/notesSlides/notesSlide4.xml><?xml version="1.0" encoding="utf-8"?>
+<p:notes xmlns:a="http://schemas.openxmlformats.org/drawingml/2006/main" xmlns:p="http://schemas.openxmlformats.org/presentationml/2006/main" xmlns:r="http://schemas.openxmlformats.org/officeDocument/2006/relationships">
+  <p:cSld>
+    <p:spTree>
+      <p:nvGrpSpPr>
+        <p:cNvPr id="1" name=""/>
+        <p:cNvGrpSpPr/>
+        <p:nvPr/>
+      </p:nvGrpSpPr>
+      <p:grpSpPr>
+        <a:xfrm>
+          <a:off x="0" y="0"/>
+          <a:ext cx="0" cy="0"/>
+          <a:chOff x="0" y="0"/>
+          <a:chExt cx="0" cy="0"/>
+        </a:xfrm>
+      </p:grpSpPr>
+      <p:sp>
+        <p:nvSpPr>
+          <p:cNvPr id="2" name="Slide Image Placeholder 1"/>
+          <p:cNvSpPr>
+            <a:spLocks noGrp="1"/>
+          </p:cNvSpPr>
+          <p:nvPr>
+            <p:ph type="sldImg" idx="2"/>
+          </p:nvPr>
+        </p:nvSpPr>
+        <p:spPr/>
+      </p:sp>
+      <p:sp>
+        <p:nvSpPr>
+          <p:cNvPr id="3" name="Notes Placeholder 2"/>
+          <p:cNvSpPr>
+            <a:spLocks noGrp="1"/>
+          </p:cNvSpPr>
+          <p:nvPr>
+            <p:ph type="body" idx="3" sz="quarter"/>
+          </p:nvPr>
+        </p:nvSpPr>
+        <p:spPr/>
+        <p:txBody>
+          <a:bodyPr/>
+          <a:lstStyle/>
+          <a:p>
+            <a:r>
+              <a:t>ANSH. Section opener. Say: these are the three books the whole project stands on.</a:t>
+            </a:r>
+          </a:p>
+        </p:txBody>
+      </p:sp>
+      <p:sp>
+        <p:nvSpPr>
+          <p:cNvPr id="4" name="Slide Number Placeholder 3"/>
+          <p:cNvSpPr>
+            <a:spLocks noGrp="1"/>
+          </p:cNvSpPr>
+          <p:nvPr>
+            <p:ph type="sldNum" idx="5" sz="quarter"/>
+          </p:nvPr>
+        </p:nvSpPr>
+        <p:spPr/>
+      </p:sp>
+    </p:spTree>
+  </p:cSld>
+  <p:clrMapOvr>
+    <a:masterClrMapping/>
+  </p:clrMapOvr>
+</p:notes>
+</file>
+
+<file path=ppt/notesSlides/notesSlide5.xml><?xml version="1.0" encoding="utf-8"?>
+<p:notes xmlns:a="http://schemas.openxmlformats.org/drawingml/2006/main" xmlns:p="http://schemas.openxmlformats.org/presentationml/2006/main" xmlns:r="http://schemas.openxmlformats.org/officeDocument/2006/relationships">
+  <p:cSld>
+    <p:spTree>
+      <p:nvGrpSpPr>
+        <p:cNvPr id="1" name=""/>
+        <p:cNvGrpSpPr/>
+        <p:nvPr/>
+      </p:nvGrpSpPr>
+      <p:grpSpPr>
+        <a:xfrm>
+          <a:off x="0" y="0"/>
+          <a:ext cx="0" cy="0"/>
+          <a:chOff x="0" y="0"/>
+          <a:chExt cx="0" cy="0"/>
+        </a:xfrm>
+      </p:grpSpPr>
+      <p:sp>
+        <p:nvSpPr>
+          <p:cNvPr id="2" name="Slide Image Placeholder 1"/>
+          <p:cNvSpPr>
+            <a:spLocks noGrp="1"/>
+          </p:cNvSpPr>
+          <p:nvPr>
+            <p:ph type="sldImg" idx="2"/>
+          </p:nvPr>
+        </p:nvSpPr>
+        <p:spPr/>
+      </p:sp>
+      <p:sp>
+        <p:nvSpPr>
+          <p:cNvPr id="3" name="Notes Placeholder 2"/>
+          <p:cNvSpPr>
+            <a:spLocks noGrp="1"/>
+          </p:cNvSpPr>
+          <p:nvPr>
+            <p:ph type="body" idx="3" sz="quarter"/>
+          </p:nvPr>
+        </p:nvSpPr>
+        <p:spPr/>
+        <p:txBody>
+          <a:bodyPr/>
+          <a:lstStyle/>
+          <a:p>
+            <a:r>
+              <a:t>ANSH.</a:t>
+            </a:r>
+          </a:p>
+          <a:p>
+            <a:r>
+              <a:t>Three sources. NPTEL from IIT Kharagpur gives the full design procedure for the cotter and</a:t>
+            </a:r>
+          </a:p>
+          <a:p>
+            <a:r>
+              <a:t>knuckle joints, the proportions and the failure modes. Unwin, 1899, gives the gib and cotter</a:t>
+            </a:r>
+          </a:p>
+          <a:p>
+            <a:r>
+              <a:t>joint, which the course does not cover. Leutwiler, 1917, lists ten ways a cotter joint fails</a:t>
+            </a:r>
+          </a:p>
+          <a:p>
+            <a:r>
+              <a:t>and analyses the flange coupling.</a:t>
+            </a:r>
+          </a:p>
+          <a:p>
+            <a:r>
+              <a:t>Two of them are out of copyright, so anyone can open them and check us.</a:t>
+            </a:r>
+          </a:p>
+          <a:p>
+            <a:r>
+              <a:t>If asked why three sources for six joints: two of them cover the same joint deliberately. That</a:t>
+            </a:r>
+          </a:p>
+          <a:p>
+            <a:r>
+              <a:t>overlap is exactly what let us find three mistakes in the books, which Dharmendra will show.</a:t>
+            </a:r>
+          </a:p>
+          <a:p>
+            <a:r>
+              <a:t>We also used SP 46 for first angle projection and the IS codes for keys, bolts and couplings.</a:t>
+            </a:r>
+          </a:p>
+        </p:txBody>
+      </p:sp>
+      <p:sp>
+        <p:nvSpPr>
+          <p:cNvPr id="4" name="Slide Number Placeholder 3"/>
+          <p:cNvSpPr>
+            <a:spLocks noGrp="1"/>
+          </p:cNvSpPr>
+          <p:nvPr>
+            <p:ph type="sldNum" idx="5" sz="quarter"/>
+          </p:nvPr>
+        </p:nvSpPr>
+        <p:spPr/>
+      </p:sp>
+    </p:spTree>
+  </p:cSld>
+  <p:clrMapOvr>
+    <a:masterClrMapping/>
+  </p:clrMapOvr>
+</p:notes>
+</file>
+
+<file path=ppt/notesSlides/notesSlide6.xml><?xml version="1.0" encoding="utf-8"?>
+<p:notes xmlns:a="http://schemas.openxmlformats.org/drawingml/2006/main" xmlns:p="http://schemas.openxmlformats.org/presentationml/2006/main" xmlns:r="http://schemas.openxmlformats.org/officeDocument/2006/relationships">
+  <p:cSld>
+    <p:spTree>
+      <p:nvGrpSpPr>
+        <p:cNvPr id="1" name=""/>
+        <p:cNvGrpSpPr/>
+        <p:nvPr/>
+      </p:nvGrpSpPr>
+      <p:grpSpPr>
+        <a:xfrm>
+          <a:off x="0" y="0"/>
+          <a:ext cx="0" cy="0"/>
+          <a:chOff x="0" y="0"/>
+          <a:chExt cx="0" cy="0"/>
+        </a:xfrm>
+      </p:grpSpPr>
+      <p:sp>
+        <p:nvSpPr>
+          <p:cNvPr id="2" name="Slide Image Placeholder 1"/>
+          <p:cNvSpPr>
+            <a:spLocks noGrp="1"/>
+          </p:cNvSpPr>
+          <p:nvPr>
+            <p:ph type="sldImg" idx="2"/>
+          </p:nvPr>
+        </p:nvSpPr>
+        <p:spPr/>
+      </p:sp>
+      <p:sp>
+        <p:nvSpPr>
+          <p:cNvPr id="3" name="Notes Placeholder 2"/>
+          <p:cNvSpPr>
+            <a:spLocks noGrp="1"/>
+          </p:cNvSpPr>
+          <p:nvPr>
+            <p:ph type="body" idx="3" sz="quarter"/>
+          </p:nvPr>
+        </p:nvSpPr>
+        <p:spPr/>
+        <p:txBody>
+          <a:bodyPr/>
+          <a:lstStyle/>
+          <a:p>
+            <a:r>
+              <a:t>ANSH.</a:t>
+            </a:r>
+          </a:p>
+          <a:p>
+            <a:r>
+              <a:t>Three existing approaches, and what each leaves open.</a:t>
+            </a:r>
+          </a:p>
+          <a:p>
+            <a:r>
+              <a:t>Parametric CAD regenerates a model when parameters change, but it does not decide the</a:t>
+            </a:r>
+          </a:p>
+          <a:p>
+            <a:r>
+              <a:t>parameters. It will regenerate an unsafe model as readily as a safe one.</a:t>
+            </a:r>
+          </a:p>
+          <a:p>
+            <a:r>
+              <a:t>Language models writing CAD code produce geometry fast, but no dimension can be traced to a</a:t>
+            </a:r>
+          </a:p>
+          <a:p>
+            <a:r>
+              <a:t>calculation and no failure mode is checked.</a:t>
+            </a:r>
+          </a:p>
+          <a:p>
+            <a:r>
+              <a:t>Expert systems are reliable but hide the calculation, so you cannot check a result against a</a:t>
+            </a:r>
+          </a:p>
+          <a:p>
+            <a:r>
+              <a:t>published source.</a:t>
+            </a:r>
+          </a:p>
+          <a:p>
+            <a:r>
+              <a:t>So the gap is not modelling and not language. It is the connection between them.</a:t>
+            </a:r>
+          </a:p>
+        </p:txBody>
+      </p:sp>
+      <p:sp>
+        <p:nvSpPr>
+          <p:cNvPr id="4" name="Slide Number Placeholder 3"/>
+          <p:cNvSpPr>
+            <a:spLocks noGrp="1"/>
+          </p:cNvSpPr>
+          <p:nvPr>
+            <p:ph type="sldNum" idx="5" sz="quarter"/>
+          </p:nvPr>
+        </p:nvSpPr>
+        <p:spPr/>
+      </p:sp>
+    </p:spTree>
+  </p:cSld>
+  <p:clrMapOvr>
+    <a:masterClrMapping/>
+  </p:clrMapOvr>
+</p:notes>
+</file>
+
+<file path=ppt/notesSlides/notesSlide7.xml><?xml version="1.0" encoding="utf-8"?>
+<p:notes xmlns:a="http://schemas.openxmlformats.org/drawingml/2006/main" xmlns:p="http://schemas.openxmlformats.org/presentationml/2006/main" xmlns:r="http://schemas.openxmlformats.org/officeDocument/2006/relationships">
+  <p:cSld>
+    <p:spTree>
+      <p:nvGrpSpPr>
+        <p:cNvPr id="1" name=""/>
+        <p:cNvGrpSpPr/>
+        <p:nvPr/>
+      </p:nvGrpSpPr>
+      <p:grpSpPr>
+        <a:xfrm>
+          <a:off x="0" y="0"/>
+          <a:ext cx="0" cy="0"/>
+          <a:chOff x="0" y="0"/>
+          <a:chExt cx="0" cy="0"/>
+        </a:xfrm>
+      </p:grpSpPr>
+      <p:sp>
+        <p:nvSpPr>
+          <p:cNvPr id="2" name="Slide Image Placeholder 1"/>
+          <p:cNvSpPr>
+            <a:spLocks noGrp="1"/>
+          </p:cNvSpPr>
+          <p:nvPr>
+            <p:ph type="sldImg" idx="2"/>
+          </p:nvPr>
+        </p:nvSpPr>
+        <p:spPr/>
+      </p:sp>
+      <p:sp>
+        <p:nvSpPr>
+          <p:cNvPr id="3" name="Notes Placeholder 2"/>
+          <p:cNvSpPr>
+            <a:spLocks noGrp="1"/>
+          </p:cNvSpPr>
+          <p:nvPr>
+            <p:ph type="body" idx="3" sz="quarter"/>
+          </p:nvPr>
+        </p:nvSpPr>
+        <p:spPr/>
+        <p:txBody>
+          <a:bodyPr/>
+          <a:lstStyle/>
+          <a:p>
+            <a:r>
+              <a:t>BHAVYA. Section opener. Say: now what we actually built.</a:t>
+            </a:r>
+          </a:p>
+        </p:txBody>
+      </p:sp>
+      <p:sp>
+        <p:nvSpPr>
+          <p:cNvPr id="4" name="Slide Number Placeholder 3"/>
+          <p:cNvSpPr>
+            <a:spLocks noGrp="1"/>
+          </p:cNvSpPr>
+          <p:nvPr>
+            <p:ph type="sldNum" idx="5" sz="quarter"/>
+          </p:nvPr>
+        </p:nvSpPr>
+        <p:spPr/>
+      </p:sp>
+    </p:spTree>
+  </p:cSld>
+  <p:clrMapOvr>
+    <a:masterClrMapping/>
+  </p:clrMapOvr>
+</p:notes>
+</file>
+
+<file path=ppt/notesSlides/notesSlide8.xml><?xml version="1.0" encoding="utf-8"?>
+<p:notes xmlns:a="http://schemas.openxmlformats.org/drawingml/2006/main" xmlns:p="http://schemas.openxmlformats.org/presentationml/2006/main" xmlns:r="http://schemas.openxmlformats.org/officeDocument/2006/relationships">
+  <p:cSld>
+    <p:spTree>
+      <p:nvGrpSpPr>
+        <p:cNvPr id="1" name=""/>
+        <p:cNvGrpSpPr/>
+        <p:nvPr/>
+      </p:nvGrpSpPr>
+      <p:grpSpPr>
+        <a:xfrm>
+          <a:off x="0" y="0"/>
+          <a:ext cx="0" cy="0"/>
+          <a:chOff x="0" y="0"/>
+          <a:chExt cx="0" cy="0"/>
+        </a:xfrm>
+      </p:grpSpPr>
+      <p:sp>
+        <p:nvSpPr>
+          <p:cNvPr id="2" name="Slide Image Placeholder 1"/>
+          <p:cNvSpPr>
+            <a:spLocks noGrp="1"/>
+          </p:cNvSpPr>
+          <p:nvPr>
+            <p:ph type="sldImg" idx="2"/>
+          </p:nvPr>
+        </p:nvSpPr>
+        <p:spPr/>
+      </p:sp>
+      <p:sp>
+        <p:nvSpPr>
+          <p:cNvPr id="3" name="Notes Placeholder 2"/>
+          <p:cNvSpPr>
+            <a:spLocks noGrp="1"/>
+          </p:cNvSpPr>
+          <p:nvPr>
+            <p:ph type="body" idx="3" sz="quarter"/>
+          </p:nvPr>
+        </p:nvSpPr>
+        <p:spPr/>
+        <p:txBody>
+          <a:bodyPr/>
+          <a:lstStyle/>
+          <a:p>
+            <a:r>
+              <a:t>BHAVYA.</a:t>
+            </a:r>
+          </a:p>
+          <a:p>
+            <a:r>
+              <a:t>Five stages. It reads the sentence into parameters. It sizes the joint starting from the</a:t>
+            </a:r>
+          </a:p>
+          <a:p>
+            <a:r>
+              <a:t>governing formula, then rounds up to a standard size as the book directs. It checks every</a:t>
+            </a:r>
+          </a:p>
+          <a:p>
+            <a:r>
+              <a:t>failure mode against the allowable stress, and where one fails it grows that dimension a</a:t>
+            </a:r>
+          </a:p>
+          <a:p>
+            <a:r>
+              <a:t>millimetre at a time until it passes. It builds each part as an exact solid. It draws the sheet.</a:t>
+            </a:r>
+          </a:p>
+          <a:p>
+            <a:r>
+              <a:t>Design rules are stored as data, not code, which is why the software can tell you the source of</a:t>
+            </a:r>
+          </a:p>
+          <a:p>
+            <a:r>
+              <a:t>any dimension at the moment it computes it.</a:t>
+            </a:r>
+          </a:p>
+        </p:txBody>
+      </p:sp>
+      <p:sp>
+        <p:nvSpPr>
+          <p:cNvPr id="4" name="Slide Number Placeholder 3"/>
+          <p:cNvSpPr>
+            <a:spLocks noGrp="1"/>
+          </p:cNvSpPr>
+          <p:nvPr>
+            <p:ph type="sldNum" idx="5" sz="quarter"/>
+          </p:nvPr>
+        </p:nvSpPr>
+        <p:spPr/>
+      </p:sp>
+    </p:spTree>
+  </p:cSld>
+  <p:clrMapOvr>
+    <a:masterClrMapping/>
+  </p:clrMapOvr>
+</p:notes>
+</file>
+
+<file path=ppt/notesSlides/notesSlide9.xml><?xml version="1.0" encoding="utf-8"?>
+<p:notes xmlns:a="http://schemas.openxmlformats.org/drawingml/2006/main" xmlns:p="http://schemas.openxmlformats.org/presentationml/2006/main" xmlns:r="http://schemas.openxmlformats.org/officeDocument/2006/relationships">
+  <p:cSld>
+    <p:spTree>
+      <p:nvGrpSpPr>
+        <p:cNvPr id="1" name=""/>
+        <p:cNvGrpSpPr/>
+        <p:nvPr/>
+      </p:nvGrpSpPr>
+      <p:grpSpPr>
+        <a:xfrm>
+          <a:off x="0" y="0"/>
+          <a:ext cx="0" cy="0"/>
+          <a:chOff x="0" y="0"/>
+          <a:chExt cx="0" cy="0"/>
+        </a:xfrm>
+      </p:grpSpPr>
+      <p:sp>
+        <p:nvSpPr>
+          <p:cNvPr id="2" name="Slide Image Placeholder 1"/>
+          <p:cNvSpPr>
+            <a:spLocks noGrp="1"/>
+          </p:cNvSpPr>
+          <p:nvPr>
+            <p:ph type="sldImg" idx="2"/>
+          </p:nvPr>
+        </p:nvSpPr>
+        <p:spPr/>
+      </p:sp>
+      <p:sp>
+        <p:nvSpPr>
+          <p:cNvPr id="3" name="Notes Placeholder 2"/>
+          <p:cNvSpPr>
+            <a:spLocks noGrp="1"/>
+          </p:cNvSpPr>
+          <p:nvPr>
+            <p:ph type="body" idx="3" sz="quarter"/>
+          </p:nvPr>
+        </p:nvSpPr>
+        <p:spPr/>
+        <p:txBody>
+          <a:bodyPr/>
+          <a:lstStyle/>
+          <a:p>
+            <a:r>
+              <a:t>BHAVYA.</a:t>
+            </a:r>
+          </a:p>
+          <a:p>
+            <a:r>
+              <a:t>This is the most important slide in the deck.</a:t>
+            </a:r>
+          </a:p>
+          <a:p>
+            <a:r>
+              <a:t>The AI only reads the sentence. It never picks a dimension and never performs a check.</a:t>
+            </a:r>
+          </a:p>
+          <a:p>
+            <a:r>
+              <a:t>Reading "50 kN" as 50,000 newtons is a language problem, and that is what a language model is</a:t>
+            </a:r>
+          </a:p>
+          <a:p>
+            <a:r>
+              <a:t>good at. Choosing the pin diameter is an engineering problem with one correct answer from a</a:t>
+            </a:r>
+          </a:p>
+          <a:p>
+            <a:r>
+              <a:t>formula, so that stays with ordinary deterministic code traceable to a page in a book.</a:t>
+            </a:r>
+          </a:p>
+          <a:p>
+            <a:r>
+              <a:t>There is also a safeguard: any number the model returns that was not in the original sentence is</a:t>
+            </a:r>
+          </a:p>
+          <a:p>
+            <a:r>
+              <a:t>thrown away and the user is told.</a:t>
+            </a:r>
+          </a:p>
+          <a:p>
+            <a:r>
+              <a:t>If asked why not let AI generate the whole model: because then no number could be checked</a:t>
+            </a:r>
+          </a:p>
+          <a:p>
+            <a:r>
+              <a:t>against anything, and geometry you cannot justify is useless in a design review.</a:t>
+            </a:r>
+          </a:p>
+        </p:txBody>
+      </p:sp>
+      <p:sp>
+        <p:nvSpPr>
+          <p:cNvPr id="4" name="Slide Number Placeholder 3"/>
+          <p:cNvSpPr>
+            <a:spLocks noGrp="1"/>
+          </p:cNvSpPr>
+          <p:nvPr>
+            <p:ph type="sldNum" idx="5" sz="quarter"/>
+          </p:nvPr>
+        </p:nvSpPr>
+        <p:spPr/>
+      </p:sp>
+    </p:spTree>
+  </p:cSld>
+  <p:clrMapOvr>
+    <a:masterClrMapping/>
+  </p:clrMapOvr>
+</p:notes>
 </file>
 
 <file path=ppt/slideLayouts/slideLayout1.xml><?xml version="1.0" encoding="utf-8"?>
@@ -4513,4 +7373,324 @@
   </a:objectDefaults>
   <a:extraClrSchemeLst/>
 </a:theme>
+</file>
+
+<file path=ppt/theme/theme2.xml><?xml version="1.0" encoding="utf-8"?>
+<a:theme xmlns:a="http://schemas.openxmlformats.org/drawingml/2006/main" name="Office Theme">
+  <a:themeElements>
+    <a:clrScheme name="Office">
+      <a:dk1>
+        <a:sysClr val="windowText" lastClr="000000"/>
+      </a:dk1>
+      <a:lt1>
+        <a:sysClr val="window" lastClr="FFFFFF"/>
+      </a:lt1>
+      <a:dk2>
+        <a:srgbClr val="1F497D"/>
+      </a:dk2>
+      <a:lt2>
+        <a:srgbClr val="EEECE1"/>
+      </a:lt2>
+      <a:accent1>
+        <a:srgbClr val="4F81BD"/>
+      </a:accent1>
+      <a:accent2>
+        <a:srgbClr val="C0504D"/>
+      </a:accent2>
+      <a:accent3>
+        <a:srgbClr val="9BBB59"/>
+      </a:accent3>
+      <a:accent4>
+        <a:srgbClr val="8064A2"/>
+      </a:accent4>
+      <a:accent5>
+        <a:srgbClr val="4BACC6"/>
+      </a:accent5>
+      <a:accent6>
+        <a:srgbClr val="F79646"/>
+      </a:accent6>
+      <a:hlink>
+        <a:srgbClr val="0000FF"/>
+      </a:hlink>
+      <a:folHlink>
+        <a:srgbClr val="800080"/>
+      </a:folHlink>
+    </a:clrScheme>
+    <a:fontScheme name="Office">
+      <a:majorFont>
+        <a:latin typeface="Calibri"/>
+        <a:ea typeface=""/>
+        <a:cs typeface=""/>
+        <a:font script="Jpan" typeface="ＭＳ Ｐゴシック"/>
+        <a:font script="Hang" typeface="맑은 고딕"/>
+        <a:font script="Hans" typeface="宋体"/>
+        <a:font script="Hant" typeface="新細明體"/>
+        <a:font script="Arab" typeface="Times New Roman"/>
+        <a:font script="Hebr" typeface="Times New Roman"/>
+        <a:font script="Thai" typeface="Angsana New"/>
+        <a:font script="Ethi" typeface="Nyala"/>
+        <a:font script="Beng" typeface="Vrinda"/>
+        <a:font script="Gujr" typeface="Shruti"/>
+        <a:font script="Khmr" typeface="MoolBoran"/>
+        <a:font script="Knda" typeface="Tunga"/>
+        <a:font script="Guru" typeface="Raavi"/>
+        <a:font script="Cans" typeface="Euphemia"/>
+        <a:font script="Cher" typeface="Plantagenet Cherokee"/>
+        <a:font script="Yiii" typeface="Microsoft Yi Baiti"/>
+        <a:font script="Tibt" typeface="Microsoft Himalaya"/>
+        <a:font script="Thaa" typeface="MV Boli"/>
+        <a:font script="Deva" typeface="Mangal"/>
+        <a:font script="Telu" typeface="Gautami"/>
+        <a:font script="Taml" typeface="Latha"/>
+        <a:font script="Syrc" typeface="Estrangelo Edessa"/>
+        <a:font script="Orya" typeface="Kalinga"/>
+        <a:font script="Mlym" typeface="Kartika"/>
+        <a:font script="Laoo" typeface="DokChampa"/>
+        <a:font script="Sinh" typeface="Iskoola Pota"/>
+        <a:font script="Mong" typeface="Mongolian Baiti"/>
+        <a:font script="Viet" typeface="Times New Roman"/>
+        <a:font script="Uigh" typeface="Microsoft Uighur"/>
+        <a:font script="Geor" typeface="Sylfaen"/>
+      </a:majorFont>
+      <a:minorFont>
+        <a:latin typeface="Calibri"/>
+        <a:ea typeface=""/>
+        <a:cs typeface=""/>
+        <a:font script="Jpan" typeface="ＭＳ Ｐゴシック"/>
+        <a:font script="Hang" typeface="맑은 고딕"/>
+        <a:font script="Hans" typeface="宋体"/>
+        <a:font script="Hant" typeface="新細明體"/>
+        <a:font script="Arab" typeface="Arial"/>
+        <a:font script="Hebr" typeface="Arial"/>
+        <a:font script="Thai" typeface="Cordia New"/>
+        <a:font script="Ethi" typeface="Nyala"/>
+        <a:font script="Beng" typeface="Vrinda"/>
+        <a:font script="Gujr" typeface="Shruti"/>
+        <a:font script="Khmr" typeface="DaunPenh"/>
+        <a:font script="Knda" typeface="Tunga"/>
+        <a:font script="Guru" typeface="Raavi"/>
+        <a:font script="Cans" typeface="Euphemia"/>
+        <a:font script="Cher" typeface="Plantagenet Cherokee"/>
+        <a:font script="Yiii" typeface="Microsoft Yi Baiti"/>
+        <a:font script="Tibt" typeface="Microsoft Himalaya"/>
+        <a:font script="Thaa" typeface="MV Boli"/>
+        <a:font script="Deva" typeface="Mangal"/>
+        <a:font script="Telu" typeface="Gautami"/>
+        <a:font script="Taml" typeface="Latha"/>
+        <a:font script="Syrc" typeface="Estrangelo Edessa"/>
+        <a:font script="Orya" typeface="Kalinga"/>
+        <a:font script="Mlym" typeface="Kartika"/>
+        <a:font script="Laoo" typeface="DokChampa"/>
+        <a:font script="Sinh" typeface="Iskoola Pota"/>
+        <a:font script="Mong" typeface="Mongolian Baiti"/>
+        <a:font script="Viet" typeface="Arial"/>
+        <a:font script="Uigh" typeface="Microsoft Uighur"/>
+        <a:font script="Geor" typeface="Sylfaen"/>
+      </a:minorFont>
+    </a:fontScheme>
+    <a:fmtScheme name="Office">
+      <a:fillStyleLst>
+        <a:solidFill>
+          <a:schemeClr val="phClr"/>
+        </a:solidFill>
+        <a:gradFill rotWithShape="1">
+          <a:gsLst>
+            <a:gs pos="0">
+              <a:schemeClr val="phClr">
+                <a:tint val="50000"/>
+                <a:satMod val="300000"/>
+              </a:schemeClr>
+            </a:gs>
+            <a:gs pos="35000">
+              <a:schemeClr val="phClr">
+                <a:tint val="37000"/>
+                <a:satMod val="300000"/>
+              </a:schemeClr>
+            </a:gs>
+            <a:gs pos="100000">
+              <a:schemeClr val="phClr">
+                <a:tint val="15000"/>
+                <a:satMod val="350000"/>
+              </a:schemeClr>
+            </a:gs>
+          </a:gsLst>
+          <a:lin ang="16200000" scaled="1"/>
+        </a:gradFill>
+        <a:gradFill rotWithShape="1">
+          <a:gsLst>
+            <a:gs pos="0">
+              <a:schemeClr val="phClr">
+                <a:tint val="100000"/>
+                <a:shade val="100000"/>
+                <a:satMod val="130000"/>
+              </a:schemeClr>
+            </a:gs>
+            <a:gs pos="100000">
+              <a:schemeClr val="phClr">
+                <a:tint val="50000"/>
+                <a:shade val="100000"/>
+                <a:satMod val="350000"/>
+              </a:schemeClr>
+            </a:gs>
+          </a:gsLst>
+          <a:lin ang="16200000" scaled="0"/>
+        </a:gradFill>
+      </a:fillStyleLst>
+      <a:lnStyleLst>
+        <a:ln w="9525" cap="flat" cmpd="sng" algn="ctr">
+          <a:solidFill>
+            <a:schemeClr val="phClr">
+              <a:shade val="95000"/>
+              <a:satMod val="105000"/>
+            </a:schemeClr>
+          </a:solidFill>
+          <a:prstDash val="solid"/>
+        </a:ln>
+        <a:ln w="25400" cap="flat" cmpd="sng" algn="ctr">
+          <a:solidFill>
+            <a:schemeClr val="phClr"/>
+          </a:solidFill>
+          <a:prstDash val="solid"/>
+        </a:ln>
+        <a:ln w="38100" cap="flat" cmpd="sng" algn="ctr">
+          <a:solidFill>
+            <a:schemeClr val="phClr"/>
+          </a:solidFill>
+          <a:prstDash val="solid"/>
+        </a:ln>
+      </a:lnStyleLst>
+      <a:effectStyleLst>
+        <a:effectStyle>
+          <a:effectLst>
+            <a:outerShdw blurRad="40000" dist="20000" dir="5400000" rotWithShape="0">
+              <a:srgbClr val="000000">
+                <a:alpha val="38000"/>
+              </a:srgbClr>
+            </a:outerShdw>
+          </a:effectLst>
+        </a:effectStyle>
+        <a:effectStyle>
+          <a:effectLst>
+            <a:outerShdw blurRad="40000" dist="23000" dir="5400000" rotWithShape="0">
+              <a:srgbClr val="000000">
+                <a:alpha val="35000"/>
+              </a:srgbClr>
+            </a:outerShdw>
+          </a:effectLst>
+        </a:effectStyle>
+        <a:effectStyle>
+          <a:effectLst>
+            <a:outerShdw blurRad="40000" dist="23000" dir="5400000" rotWithShape="0">
+              <a:srgbClr val="000000">
+                <a:alpha val="35000"/>
+              </a:srgbClr>
+            </a:outerShdw>
+          </a:effectLst>
+          <a:scene3d>
+            <a:camera prst="orthographicFront">
+              <a:rot lat="0" lon="0" rev="0"/>
+            </a:camera>
+            <a:lightRig rig="threePt" dir="t">
+              <a:rot lat="0" lon="0" rev="1200000"/>
+            </a:lightRig>
+          </a:scene3d>
+          <a:sp3d>
+            <a:bevelT w="63500" h="25400"/>
+          </a:sp3d>
+        </a:effectStyle>
+      </a:effectStyleLst>
+      <a:bgFillStyleLst>
+        <a:solidFill>
+          <a:schemeClr val="phClr"/>
+        </a:solidFill>
+        <a:gradFill rotWithShape="1">
+          <a:gsLst>
+            <a:gs pos="0">
+              <a:schemeClr val="phClr">
+                <a:tint val="40000"/>
+                <a:satMod val="350000"/>
+              </a:schemeClr>
+            </a:gs>
+            <a:gs pos="40000">
+              <a:schemeClr val="phClr">
+                <a:tint val="45000"/>
+                <a:shade val="99000"/>
+                <a:satMod val="350000"/>
+              </a:schemeClr>
+            </a:gs>
+            <a:gs pos="100000">
+              <a:schemeClr val="phClr">
+                <a:shade val="20000"/>
+                <a:satMod val="255000"/>
+              </a:schemeClr>
+            </a:gs>
+          </a:gsLst>
+          <a:path path="circle">
+            <a:fillToRect l="50000" t="-80000" r="50000" b="180000"/>
+          </a:path>
+        </a:gradFill>
+        <a:gradFill rotWithShape="1">
+          <a:gsLst>
+            <a:gs pos="0">
+              <a:schemeClr val="phClr">
+                <a:tint val="80000"/>
+                <a:satMod val="300000"/>
+              </a:schemeClr>
+            </a:gs>
+            <a:gs pos="100000">
+              <a:schemeClr val="phClr">
+                <a:shade val="30000"/>
+                <a:satMod val="200000"/>
+              </a:schemeClr>
+            </a:gs>
+          </a:gsLst>
+          <a:path path="circle">
+            <a:fillToRect l="50000" t="50000" r="50000" b="50000"/>
+          </a:path>
+        </a:gradFill>
+      </a:bgFillStyleLst>
+    </a:fmtScheme>
+  </a:themeElements>
+  <a:objectDefaults>
+    <a:spDef>
+      <a:spPr/>
+      <a:bodyPr/>
+      <a:lstStyle/>
+      <a:style>
+        <a:lnRef idx="1">
+          <a:schemeClr val="accent1"/>
+        </a:lnRef>
+        <a:fillRef idx="3">
+          <a:schemeClr val="accent1"/>
+        </a:fillRef>
+        <a:effectRef idx="2">
+          <a:schemeClr val="accent1"/>
+        </a:effectRef>
+        <a:fontRef idx="minor">
+          <a:schemeClr val="lt1"/>
+        </a:fontRef>
+      </a:style>
+    </a:spDef>
+    <a:lnDef>
+      <a:spPr/>
+      <a:bodyPr/>
+      <a:lstStyle/>
+      <a:style>
+        <a:lnRef idx="2">
+          <a:schemeClr val="accent1"/>
+        </a:lnRef>
+        <a:fillRef idx="0">
+          <a:schemeClr val="accent1"/>
+        </a:fillRef>
+        <a:effectRef idx="1">
+          <a:schemeClr val="accent1"/>
+        </a:effectRef>
+        <a:fontRef idx="minor">
+          <a:schemeClr val="tx1"/>
+        </a:fontRef>
+      </a:style>
+    </a:lnDef>
+  </a:objectDefaults>
+  <a:extraClrSchemeLst/>
+</a:theme>
 </file>
</xml_diff>

<commit_message>
mac exit 2026-10-27: everything local, as-is
</commit_message>
<xml_diff>
--- a/report/AI-in-CAD-Major-Project-Presentation.pptx
+++ b/report/AI-in-CAD-Major-Project-Presentation.pptx
@@ -31,6 +31,9 @@
     <p:sldId id="279" r:id="rId31"/>
     <p:sldId id="280" r:id="rId32"/>
     <p:sldId id="281" r:id="rId33"/>
+    <p:sldId id="282" r:id="rId34"/>
+    <p:sldId id="283" r:id="rId35"/>
+    <p:sldId id="284" r:id="rId36"/>
   </p:sldIdLst>
   <p:sldSz cx="12191695" cy="6858000" type="screen4x3"/>
   <p:notesSz cx="6858000" cy="9144000"/>
@@ -1210,6 +1213,11 @@
               <a:t>STEP is a neutral format, so the output is not locked to our software.</a:t>
             </a:r>
           </a:p>
+          <a:p>
+            <a:r>
+              <a:t>Next slide shows exactly what that NX claim rests on.</a:t>
+            </a:r>
+          </a:p>
         </p:txBody>
       </p:sp>
       <p:sp>
@@ -1282,22 +1290,52 @@
           </a:p>
           <a:p>
             <a:r>
-              <a:t>The assembled model, which rotates in the browser, and the same joint coloured by how close each</a:t>
-            </a:r>
-          </a:p>
-          <a:p>
-            <a:r>
-              <a:t>part is to its limit.</a:t>
-            </a:r>
-          </a:p>
-          <a:p>
-            <a:r>
-              <a:t>The colouring is useful because it puts the weakest member in front of you without reading a</a:t>
-            </a:r>
-          </a:p>
-          <a:p>
-            <a:r>
-              <a:t>table.</a:t>
+              <a:t>One of our stated objectives is that the output opens in commercial CAD, specifically NX10,</a:t>
+            </a:r>
+          </a:p>
+          <a:p>
+            <a:r>
+              <a:t>since that is what we are taught on in the lab. Here is what we actually checked, not what we</a:t>
+            </a:r>
+          </a:p>
+          <a:p>
+            <a:r>
+              <a:t>assumed.</a:t>
+            </a:r>
+          </a:p>
+          <a:p>
+            <a:r>
+              <a:t>We opened the exported file as text and read it directly. The schema line reads AUTOMOTIVE</a:t>
+            </a:r>
+          </a:p>
+          <a:p>
+            <a:r>
+              <a:t>DESIGN, AP214, which is the exact STEP format NX10 reads natively. Inside it, four separate</a:t>
+            </a:r>
+          </a:p>
+          <a:p>
+            <a:r>
+              <a:t>named parts, rod, strap, cotter, gib, each its own solid, not fused into one body. That is the</a:t>
+            </a:r>
+          </a:p>
+          <a:p>
+            <a:r>
+              <a:t>structure an assembly import needs.</a:t>
+            </a:r>
+          </a:p>
+          <a:p>
+            <a:r>
+              <a:t>We are saying this plainly: opening it inside NX10 itself still needs a lab machine, which</a:t>
+            </a:r>
+          </a:p>
+          <a:p>
+            <a:r>
+              <a:t>none of us has done yet. If asked, say exactly that, do not claim it was opened when it was not.</a:t>
+            </a:r>
+          </a:p>
+          <a:p>
+            <a:r>
+              <a:t>We verified the file is built correctly; we have not yet watched NX10 read it.</a:t>
             </a:r>
           </a:p>
         </p:txBody>
@@ -1367,7 +1405,27 @@
           <a:lstStyle/>
           <a:p>
             <a:r>
-              <a:t>DHARMENDRA. Section opener. Say: now, how do we know any of this is correct.</a:t>
+              <a:t>ATISHAY.</a:t>
+            </a:r>
+          </a:p>
+          <a:p>
+            <a:r>
+              <a:t>The assembled model, which rotates in the browser, and the same joint coloured by how close each</a:t>
+            </a:r>
+          </a:p>
+          <a:p>
+            <a:r>
+              <a:t>part is to its limit.</a:t>
+            </a:r>
+          </a:p>
+          <a:p>
+            <a:r>
+              <a:t>The colouring is useful because it puts the weakest member in front of you without reading a</a:t>
+            </a:r>
+          </a:p>
+          <a:p>
+            <a:r>
+              <a:t>table.</a:t>
             </a:r>
           </a:p>
         </p:txBody>
@@ -1437,52 +1495,7 @@
           <a:lstStyle/>
           <a:p>
             <a:r>
-              <a:t>DHARMENDRA.</a:t>
-            </a:r>
-          </a:p>
-          <a:p>
-            <a:r>
-              <a:t>Every proportion and every check was compared against the three sources.</a:t>
-            </a:r>
-          </a:p>
-          <a:p>
-            <a:r>
-              <a:t>Knuckle and cotter are fully verified. The cotter joint is verified twice over, against two</a:t>
-            </a:r>
-          </a:p>
-          <a:p>
-            <a:r>
-              <a:t>independent books.</a:t>
-            </a:r>
-          </a:p>
-          <a:p>
-            <a:r>
-              <a:t>Two entries are honest limitations rather than gaps. For the flange coupling all seven checks</a:t>
-            </a:r>
-          </a:p>
-          <a:p>
-            <a:r>
-              <a:t>are verified twice, but the proportions cannot be verified, because Leutwiler records that no</a:t>
-            </a:r>
-          </a:p>
-          <a:p>
-            <a:r>
-              <a:t>standard set of flange coupling proportions was ever agreed and that published tables are</a:t>
-            </a:r>
-          </a:p>
-          <a:p>
-            <a:r>
-              <a:t>individual manufacturers' practice. For the sleeve and cotter joint we searched four books and</a:t>
-            </a:r>
-          </a:p>
-          <a:p>
-            <a:r>
-              <a:t>none covers it by name.</a:t>
-            </a:r>
-          </a:p>
-          <a:p>
-            <a:r>
-              <a:t>Where no source exists, the software says so on every single run rather than implying one.</a:t>
+              <a:t>DHARMENDRA. Section opener. Say: now, how do we know any of this is correct.</a:t>
             </a:r>
           </a:p>
         </p:txBody>
@@ -1627,37 +1640,47 @@
           </a:p>
           <a:p>
             <a:r>
-              <a:t>The first of three errors we found in the published sources.</a:t>
-            </a:r>
-          </a:p>
-          <a:p>
-            <a:r>
-              <a:t>The knuckle worked problem raises the pin from 40 to 55 millimetres to satisfy bending, then</a:t>
-            </a:r>
-          </a:p>
-          <a:p>
-            <a:r>
-              <a:t>checks the eye using the original 40 millimetre pin.</a:t>
-            </a:r>
-          </a:p>
-          <a:p>
-            <a:r>
-              <a:t>Put the pin it actually adopted into its own expression and you get 80 MPa against an allowable</a:t>
-            </a:r>
-          </a:p>
-          <a:p>
-            <a:r>
-              <a:t>of 65. Its own answer fails its own check by 23 percent.</a:t>
-            </a:r>
-          </a:p>
-          <a:p>
-            <a:r>
-              <a:t>Our software instead enlarges the outer diameter of the eye until the check passes, and reports</a:t>
-            </a:r>
-          </a:p>
-          <a:p>
-            <a:r>
-              <a:t>that it has done so.</a:t>
+              <a:t>Every proportion and every check was compared against the three sources.</a:t>
+            </a:r>
+          </a:p>
+          <a:p>
+            <a:r>
+              <a:t>Knuckle and cotter are fully verified. The cotter joint is verified twice over, against two</a:t>
+            </a:r>
+          </a:p>
+          <a:p>
+            <a:r>
+              <a:t>independent books.</a:t>
+            </a:r>
+          </a:p>
+          <a:p>
+            <a:r>
+              <a:t>Two entries are honest limitations rather than gaps. For the flange coupling all seven checks</a:t>
+            </a:r>
+          </a:p>
+          <a:p>
+            <a:r>
+              <a:t>are verified twice, but the proportions cannot be verified, because Leutwiler records that no</a:t>
+            </a:r>
+          </a:p>
+          <a:p>
+            <a:r>
+              <a:t>standard set of flange coupling proportions was ever agreed and that published tables are</a:t>
+            </a:r>
+          </a:p>
+          <a:p>
+            <a:r>
+              <a:t>individual manufacturers' practice. For the sleeve and cotter joint we searched four books and</a:t>
+            </a:r>
+          </a:p>
+          <a:p>
+            <a:r>
+              <a:t>none covers it by name.</a:t>
+            </a:r>
+          </a:p>
+          <a:p>
+            <a:r>
+              <a:t>Where no source exists, the software says so on every single run rather than implying one.</a:t>
             </a:r>
           </a:p>
         </p:txBody>
@@ -1732,47 +1755,37 @@
           </a:p>
           <a:p>
             <a:r>
-              <a:t>Two more.</a:t>
-            </a:r>
-          </a:p>
-          <a:p>
-            <a:r>
-              <a:t>The cotter procedure checks crushing of the socket but never crushing between the cotter and the</a:t>
-            </a:r>
-          </a:p>
-          <a:p>
-            <a:r>
-              <a:t>spigot. At its own final answer that omitted check reads 167 MPa against 110 allowed. Leutwiler</a:t>
-            </a:r>
-          </a:p>
-          <a:p>
-            <a:r>
-              <a:t>lists it as one of ten failure modes, which is what makes it an omission and not a preference.</a:t>
-            </a:r>
-          </a:p>
-          <a:p>
-            <a:r>
-              <a:t>Second, the bolt tightening constant is printed as 284 d kilonewtons, but the worked example on</a:t>
-            </a:r>
-          </a:p>
-          <a:p>
-            <a:r>
-              <a:t>the same page gives 56.8 kN for an M20 bolt. That only works if the constant is 2840 d newtons.</a:t>
-            </a:r>
-          </a:p>
-          <a:p>
-            <a:r>
-              <a:t>The page refutes itself, and it is out by a factor of ten.</a:t>
-            </a:r>
-          </a:p>
-          <a:p>
-            <a:r>
-              <a:t>We found none of these by reading. We found them because the software computes every check and</a:t>
-            </a:r>
-          </a:p>
-          <a:p>
-            <a:r>
-              <a:t>prints the arithmetic.</a:t>
+              <a:t>The first of three errors we found in the published sources.</a:t>
+            </a:r>
+          </a:p>
+          <a:p>
+            <a:r>
+              <a:t>The knuckle worked problem raises the pin from 40 to 55 millimetres to satisfy bending, then</a:t>
+            </a:r>
+          </a:p>
+          <a:p>
+            <a:r>
+              <a:t>checks the eye using the original 40 millimetre pin.</a:t>
+            </a:r>
+          </a:p>
+          <a:p>
+            <a:r>
+              <a:t>Put the pin it actually adopted into its own expression and you get 80 MPa against an allowable</a:t>
+            </a:r>
+          </a:p>
+          <a:p>
+            <a:r>
+              <a:t>of 65. Its own answer fails its own check by 23 percent.</a:t>
+            </a:r>
+          </a:p>
+          <a:p>
+            <a:r>
+              <a:t>Our software instead enlarges the outer diameter of the eye until the check passes, and reports</a:t>
+            </a:r>
+          </a:p>
+          <a:p>
+            <a:r>
+              <a:t>that it has done so.</a:t>
             </a:r>
           </a:p>
         </p:txBody>
@@ -1842,7 +1855,52 @@
           <a:lstStyle/>
           <a:p>
             <a:r>
-              <a:t>ANKUR. Section opener. Say: finally, how the work is validated and what it does not do.</a:t>
+              <a:t>DHARMENDRA.</a:t>
+            </a:r>
+          </a:p>
+          <a:p>
+            <a:r>
+              <a:t>Two more.</a:t>
+            </a:r>
+          </a:p>
+          <a:p>
+            <a:r>
+              <a:t>The cotter procedure checks crushing of the socket but never crushing between the cotter and the</a:t>
+            </a:r>
+          </a:p>
+          <a:p>
+            <a:r>
+              <a:t>spigot. At its own final answer that omitted check reads 167 MPa against 110 allowed. Leutwiler</a:t>
+            </a:r>
+          </a:p>
+          <a:p>
+            <a:r>
+              <a:t>lists it as one of ten failure modes, which is what makes it an omission and not a preference.</a:t>
+            </a:r>
+          </a:p>
+          <a:p>
+            <a:r>
+              <a:t>Second, the bolt tightening constant is printed as 284 d kilonewtons, but the worked example on</a:t>
+            </a:r>
+          </a:p>
+          <a:p>
+            <a:r>
+              <a:t>the same page gives 56.8 kN for an M20 bolt. That only works if the constant is 2840 d newtons.</a:t>
+            </a:r>
+          </a:p>
+          <a:p>
+            <a:r>
+              <a:t>The page refutes itself, and it is out by a factor of ten.</a:t>
+            </a:r>
+          </a:p>
+          <a:p>
+            <a:r>
+              <a:t>We found none of these by reading. We found them because the software computes every check and</a:t>
+            </a:r>
+          </a:p>
+          <a:p>
+            <a:r>
+              <a:t>prints the arithmetic.</a:t>
             </a:r>
           </a:p>
         </p:txBody>
@@ -1912,57 +1970,7 @@
           <a:lstStyle/>
           <a:p>
             <a:r>
-              <a:t>ANKUR.</a:t>
-            </a:r>
-          </a:p>
-          <a:p>
-            <a:r>
-              <a:t>An independent finite element cross check.</a:t>
-            </a:r>
-          </a:p>
-          <a:p>
-            <a:r>
-              <a:t>First validated on a case with a known answer: a 20 mm bar in tension, formula 31.83, computed</a:t>
-            </a:r>
-          </a:p>
-          <a:p>
-            <a:r>
-              <a:t>32.22, a difference of 1.2 percent.</a:t>
-            </a:r>
-          </a:p>
-          <a:p>
-            <a:r>
-              <a:t>On the knuckle eye rod: formula 52.0, computed 57.9, about 11.5 percent higher. That is expected,</a:t>
-            </a:r>
-          </a:p>
-          <a:p>
-            <a:r>
-              <a:t>because the formula treats the rod as a plain bar and ignores the stress raised at the pin bore.</a:t>
-            </a:r>
-          </a:p>
-          <a:p>
-            <a:r>
-              <a:t>Both stay under the 75 MPa allowable.</a:t>
-            </a:r>
-          </a:p>
-          <a:p>
-            <a:r>
-              <a:t>The important part: a peak that never settles is not a stress. On one part the computed peak</a:t>
-            </a:r>
-          </a:p>
-          <a:p>
-            <a:r>
-              <a:t>moved between 157 and 191 MPa as we refined the mesh sixteen fold. So the software re-solves on</a:t>
-            </a:r>
-          </a:p>
-          <a:p>
-            <a:r>
-              <a:t>a finer mesh and reports NOT CONVERGED when the number will not settle, and tells you to design</a:t>
-            </a:r>
-          </a:p>
-          <a:p>
-            <a:r>
-              <a:t>to the hand calculation.</a:t>
+              <a:t>ANKUR. Section opener. Say: finally, how the work is validated and what it does not do.</a:t>
             </a:r>
           </a:p>
         </p:txBody>
@@ -2037,42 +2045,52 @@
           </a:p>
           <a:p>
             <a:r>
-              <a:t>290 automated tests run on every change: the arithmetic, the geometry, the parsing, the drawing</a:t>
-            </a:r>
-          </a:p>
-          <a:p>
-            <a:r>
-              <a:t>and the analysis.</a:t>
-            </a:r>
-          </a:p>
-          <a:p>
-            <a:r>
-              <a:t>The row that matters most is the last one. There are tests that assert the three errors in the</a:t>
-            </a:r>
-          </a:p>
-          <a:p>
-            <a:r>
-              <a:t>books are real. Without them, someone could later correct our software back to the printed</a:t>
-            </a:r>
-          </a:p>
-          <a:p>
-            <a:r>
-              <a:t>answers and every other test would still pass.</a:t>
-            </a:r>
-          </a:p>
-          <a:p>
-            <a:r>
-              <a:t>One test found something no dimension check could: comparing the solids pairwise caught a gib</a:t>
-            </a:r>
-          </a:p>
-          <a:p>
-            <a:r>
-              <a:t>hook modelled 1.25 millimetres inside the strap, occupying metal another part already occupied,</a:t>
-            </a:r>
-          </a:p>
-          <a:p>
-            <a:r>
-              <a:t>while every individual dimension was correct.</a:t>
+              <a:t>An independent finite element cross check.</a:t>
+            </a:r>
+          </a:p>
+          <a:p>
+            <a:r>
+              <a:t>First validated on a case with a known answer: a 20 mm bar in tension, formula 31.83, computed</a:t>
+            </a:r>
+          </a:p>
+          <a:p>
+            <a:r>
+              <a:t>32.22, a difference of 1.2 percent.</a:t>
+            </a:r>
+          </a:p>
+          <a:p>
+            <a:r>
+              <a:t>On the knuckle eye rod: formula 52.0, computed 57.9, about 11.5 percent higher. That is expected,</a:t>
+            </a:r>
+          </a:p>
+          <a:p>
+            <a:r>
+              <a:t>because the formula treats the rod as a plain bar and ignores the stress raised at the pin bore.</a:t>
+            </a:r>
+          </a:p>
+          <a:p>
+            <a:r>
+              <a:t>Both stay under the 75 MPa allowable.</a:t>
+            </a:r>
+          </a:p>
+          <a:p>
+            <a:r>
+              <a:t>The important part: a peak that never settles is not a stress. On one part the computed peak</a:t>
+            </a:r>
+          </a:p>
+          <a:p>
+            <a:r>
+              <a:t>moved between 157 and 191 MPa as we refined the mesh sixteen fold. So the software re-solves on</a:t>
+            </a:r>
+          </a:p>
+          <a:p>
+            <a:r>
+              <a:t>a finer mesh and reports NOT CONVERGED when the number will not settle, and tells you to design</a:t>
+            </a:r>
+          </a:p>
+          <a:p>
+            <a:r>
+              <a:t>to the hand calculation.</a:t>
             </a:r>
           </a:p>
         </p:txBody>
@@ -2147,37 +2165,42 @@
           </a:p>
           <a:p>
             <a:r>
-              <a:t>What it does not do, said before anyone asks.</a:t>
-            </a:r>
-          </a:p>
-          <a:p>
-            <a:r>
-              <a:t>Static loading only, so no fatigue and no stress concentration factors. Nominal dimensions only,</a:t>
-            </a:r>
-          </a:p>
-          <a:p>
-            <a:r>
-              <a:t>so no tolerances or fits, which means the sheet is not yet a manufacturing drawing. Two of the</a:t>
-            </a:r>
-          </a:p>
-          <a:p>
-            <a:r>
-              <a:t>six joints have proportions with no book behind them, and the software says so every run. Nut</a:t>
-            </a:r>
-          </a:p>
-          <a:p>
-            <a:r>
-              <a:t>thread stripping is not checked.</a:t>
-            </a:r>
-          </a:p>
-          <a:p>
-            <a:r>
-              <a:t>Future scope: riveted and welded joints follow the same pattern, then fatigue, then tolerances</a:t>
-            </a:r>
-          </a:p>
-          <a:p>
-            <a:r>
-              <a:t>and fits, then a journal script so the assembly builds inside NX rather than being imported.</a:t>
+              <a:t>290 automated tests run on every change: the arithmetic, the geometry, the parsing, the drawing</a:t>
+            </a:r>
+          </a:p>
+          <a:p>
+            <a:r>
+              <a:t>and the analysis.</a:t>
+            </a:r>
+          </a:p>
+          <a:p>
+            <a:r>
+              <a:t>The row that matters most is the last one. There are tests that assert the three errors in the</a:t>
+            </a:r>
+          </a:p>
+          <a:p>
+            <a:r>
+              <a:t>books are real. Without them, someone could later correct our software back to the printed</a:t>
+            </a:r>
+          </a:p>
+          <a:p>
+            <a:r>
+              <a:t>answers and every other test would still pass.</a:t>
+            </a:r>
+          </a:p>
+          <a:p>
+            <a:r>
+              <a:t>One test found something no dimension check could: comparing the solids pairwise caught a gib</a:t>
+            </a:r>
+          </a:p>
+          <a:p>
+            <a:r>
+              <a:t>hook modelled 1.25 millimetres inside the strap, occupying metal another part already occupied,</a:t>
+            </a:r>
+          </a:p>
+          <a:p>
+            <a:r>
+              <a:t>while every individual dimension was correct.</a:t>
             </a:r>
           </a:p>
         </p:txBody>
@@ -2203,6 +2226,351 @@
 </file>
 
 <file path=ppt/notesSlides/notesSlide26.xml><?xml version="1.0" encoding="utf-8"?>
+<p:notes xmlns:a="http://schemas.openxmlformats.org/drawingml/2006/main" xmlns:p="http://schemas.openxmlformats.org/presentationml/2006/main" xmlns:r="http://schemas.openxmlformats.org/officeDocument/2006/relationships">
+  <p:cSld>
+    <p:spTree>
+      <p:nvGrpSpPr>
+        <p:cNvPr id="1" name=""/>
+        <p:cNvGrpSpPr/>
+        <p:nvPr/>
+      </p:nvGrpSpPr>
+      <p:grpSpPr>
+        <a:xfrm>
+          <a:off x="0" y="0"/>
+          <a:ext cx="0" cy="0"/>
+          <a:chOff x="0" y="0"/>
+          <a:chExt cx="0" cy="0"/>
+        </a:xfrm>
+      </p:grpSpPr>
+      <p:sp>
+        <p:nvSpPr>
+          <p:cNvPr id="2" name="Slide Image Placeholder 1"/>
+          <p:cNvSpPr>
+            <a:spLocks noGrp="1"/>
+          </p:cNvSpPr>
+          <p:nvPr>
+            <p:ph type="sldImg" idx="2"/>
+          </p:nvPr>
+        </p:nvSpPr>
+        <p:spPr/>
+      </p:sp>
+      <p:sp>
+        <p:nvSpPr>
+          <p:cNvPr id="3" name="Notes Placeholder 2"/>
+          <p:cNvSpPr>
+            <a:spLocks noGrp="1"/>
+          </p:cNvSpPr>
+          <p:nvPr>
+            <p:ph type="body" idx="3" sz="quarter"/>
+          </p:nvPr>
+        </p:nvSpPr>
+        <p:spPr/>
+        <p:txBody>
+          <a:bodyPr/>
+          <a:lstStyle/>
+          <a:p>
+            <a:r>
+              <a:t>ANKUR.</a:t>
+            </a:r>
+          </a:p>
+          <a:p>
+            <a:r>
+              <a:t>What it does not do, said before anyone asks.</a:t>
+            </a:r>
+          </a:p>
+          <a:p>
+            <a:r>
+              <a:t>Static loading only, so no fatigue and no stress concentration factors. Nominal dimensions only,</a:t>
+            </a:r>
+          </a:p>
+          <a:p>
+            <a:r>
+              <a:t>so no tolerances or fits, which means the sheet is not yet a manufacturing drawing. Two of the</a:t>
+            </a:r>
+          </a:p>
+          <a:p>
+            <a:r>
+              <a:t>six joints have proportions with no book behind them, and the software says so every run. Nut</a:t>
+            </a:r>
+          </a:p>
+          <a:p>
+            <a:r>
+              <a:t>thread stripping is not checked.</a:t>
+            </a:r>
+          </a:p>
+          <a:p>
+            <a:r>
+              <a:t>Future scope: riveted and welded joints follow the same pattern, then fatigue, then tolerances</a:t>
+            </a:r>
+          </a:p>
+          <a:p>
+            <a:r>
+              <a:t>and fits, then a journal script so the assembly builds inside NX rather than being imported.</a:t>
+            </a:r>
+          </a:p>
+        </p:txBody>
+      </p:sp>
+      <p:sp>
+        <p:nvSpPr>
+          <p:cNvPr id="4" name="Slide Number Placeholder 3"/>
+          <p:cNvSpPr>
+            <a:spLocks noGrp="1"/>
+          </p:cNvSpPr>
+          <p:nvPr>
+            <p:ph type="sldNum" idx="5" sz="quarter"/>
+          </p:nvPr>
+        </p:nvSpPr>
+        <p:spPr/>
+      </p:sp>
+    </p:spTree>
+  </p:cSld>
+  <p:clrMapOvr>
+    <a:masterClrMapping/>
+  </p:clrMapOvr>
+</p:notes>
+</file>
+
+<file path=ppt/notesSlides/notesSlide27.xml><?xml version="1.0" encoding="utf-8"?>
+<p:notes xmlns:a="http://schemas.openxmlformats.org/drawingml/2006/main" xmlns:p="http://schemas.openxmlformats.org/presentationml/2006/main" xmlns:r="http://schemas.openxmlformats.org/officeDocument/2006/relationships">
+  <p:cSld>
+    <p:spTree>
+      <p:nvGrpSpPr>
+        <p:cNvPr id="1" name=""/>
+        <p:cNvGrpSpPr/>
+        <p:nvPr/>
+      </p:nvGrpSpPr>
+      <p:grpSpPr>
+        <a:xfrm>
+          <a:off x="0" y="0"/>
+          <a:ext cx="0" cy="0"/>
+          <a:chOff x="0" y="0"/>
+          <a:chExt cx="0" cy="0"/>
+        </a:xfrm>
+      </p:grpSpPr>
+      <p:sp>
+        <p:nvSpPr>
+          <p:cNvPr id="2" name="Slide Image Placeholder 1"/>
+          <p:cNvSpPr>
+            <a:spLocks noGrp="1"/>
+          </p:cNvSpPr>
+          <p:nvPr>
+            <p:ph type="sldImg" idx="2"/>
+          </p:nvPr>
+        </p:nvSpPr>
+        <p:spPr/>
+      </p:sp>
+      <p:sp>
+        <p:nvSpPr>
+          <p:cNvPr id="3" name="Notes Placeholder 2"/>
+          <p:cNvSpPr>
+            <a:spLocks noGrp="1"/>
+          </p:cNvSpPr>
+          <p:nvPr>
+            <p:ph type="body" idx="3" sz="quarter"/>
+          </p:nvPr>
+        </p:nvSpPr>
+        <p:spPr/>
+        <p:txBody>
+          <a:bodyPr/>
+          <a:lstStyle/>
+          <a:p>
+            <a:r>
+              <a:t>ANKUR.</a:t>
+            </a:r>
+          </a:p>
+          <a:p>
+            <a:r>
+              <a:t>Six objectives, set out at the start, each checked against the evidence rather than restated as</a:t>
+            </a:r>
+          </a:p>
+          <a:p>
+            <a:r>
+              <a:t>done.</a:t>
+            </a:r>
+          </a:p>
+          <a:p>
+            <a:r>
+              <a:t>Five of six are met without qualification: reading plain English, sizing and verifying with</a:t>
+            </a:r>
+          </a:p>
+          <a:p>
+            <a:r>
+              <a:t>iteration, the drawing sheet, verification against literature, and browser use without install.</a:t>
+            </a:r>
+          </a:p>
+          <a:p>
+            <a:r>
+              <a:t>The sixth, opening the exported file inside NX10 itself, is met in structure, AP214 schema, four</a:t>
+            </a:r>
+          </a:p>
+          <a:p>
+            <a:r>
+              <a:t>separate solids, but not yet confirmed by watching it actually open there.</a:t>
+            </a:r>
+          </a:p>
+          <a:p>
+            <a:r>
+              <a:t>If asked why show this at all instead of just claiming six for six: because recording the gap</a:t>
+            </a:r>
+          </a:p>
+          <a:p>
+            <a:r>
+              <a:t>honestly is itself part of what Objective 5 asked for. A scorecard that hides its one open item</a:t>
+            </a:r>
+          </a:p>
+          <a:p>
+            <a:r>
+              <a:t>would undercut the exact thing it is trying to demonstrate.</a:t>
+            </a:r>
+          </a:p>
+        </p:txBody>
+      </p:sp>
+      <p:sp>
+        <p:nvSpPr>
+          <p:cNvPr id="4" name="Slide Number Placeholder 3"/>
+          <p:cNvSpPr>
+            <a:spLocks noGrp="1"/>
+          </p:cNvSpPr>
+          <p:nvPr>
+            <p:ph type="sldNum" idx="5" sz="quarter"/>
+          </p:nvPr>
+        </p:nvSpPr>
+        <p:spPr/>
+      </p:sp>
+    </p:spTree>
+  </p:cSld>
+  <p:clrMapOvr>
+    <a:masterClrMapping/>
+  </p:clrMapOvr>
+</p:notes>
+</file>
+
+<file path=ppt/notesSlides/notesSlide28.xml><?xml version="1.0" encoding="utf-8"?>
+<p:notes xmlns:a="http://schemas.openxmlformats.org/drawingml/2006/main" xmlns:p="http://schemas.openxmlformats.org/presentationml/2006/main" xmlns:r="http://schemas.openxmlformats.org/officeDocument/2006/relationships">
+  <p:cSld>
+    <p:spTree>
+      <p:nvGrpSpPr>
+        <p:cNvPr id="1" name=""/>
+        <p:cNvGrpSpPr/>
+        <p:nvPr/>
+      </p:nvGrpSpPr>
+      <p:grpSpPr>
+        <a:xfrm>
+          <a:off x="0" y="0"/>
+          <a:ext cx="0" cy="0"/>
+          <a:chOff x="0" y="0"/>
+          <a:chExt cx="0" cy="0"/>
+        </a:xfrm>
+      </p:grpSpPr>
+      <p:sp>
+        <p:nvSpPr>
+          <p:cNvPr id="2" name="Slide Image Placeholder 1"/>
+          <p:cNvSpPr>
+            <a:spLocks noGrp="1"/>
+          </p:cNvSpPr>
+          <p:nvPr>
+            <p:ph type="sldImg" idx="2"/>
+          </p:nvPr>
+        </p:nvSpPr>
+        <p:spPr/>
+      </p:sp>
+      <p:sp>
+        <p:nvSpPr>
+          <p:cNvPr id="3" name="Notes Placeholder 2"/>
+          <p:cNvSpPr>
+            <a:spLocks noGrp="1"/>
+          </p:cNvSpPr>
+          <p:nvPr>
+            <p:ph type="body" idx="3" sz="quarter"/>
+          </p:nvPr>
+        </p:nvSpPr>
+        <p:spPr/>
+        <p:txBody>
+          <a:bodyPr/>
+          <a:lstStyle/>
+          <a:p>
+            <a:r>
+              <a:t>ANKUR.</a:t>
+            </a:r>
+          </a:p>
+          <a:p>
+            <a:r>
+              <a:t>The timeline.</a:t>
+            </a:r>
+          </a:p>
+          <a:p>
+            <a:r>
+              <a:t>Green is finished, amber is where we stand today, grey is what we propose for semester eight.</a:t>
+            </a:r>
+          </a:p>
+          <a:p>
+            <a:r>
+              <a:t>Everything you have seen in this presentation is in the green and amber blocks.</a:t>
+            </a:r>
+          </a:p>
+          <a:p>
+            <a:r>
+              <a:t>Phase one was the literature and the design procedure. Phase two was the sizing engine and all</a:t>
+            </a:r>
+          </a:p>
+          <a:p>
+            <a:r>
+              <a:t>six joints with their forty-four checks. Phase three, where we are now, is the solid modelling,</a:t>
+            </a:r>
+          </a:p>
+          <a:p>
+            <a:r>
+              <a:t>the drawing sheet, the verification against the three books, the finite element cross check,</a:t>
+            </a:r>
+          </a:p>
+          <a:p>
+            <a:r>
+              <a:t>the tests and the deployment.</a:t>
+            </a:r>
+          </a:p>
+          <a:p>
+            <a:r>
+              <a:t>Semester eight is a proposal taken from the limits on the previous slide, to be agreed with our</a:t>
+            </a:r>
+          </a:p>
+          <a:p>
+            <a:r>
+              <a:t>guide: riveted and welded joints, fatigue, tolerances and fits, the two proportion sets that</a:t>
+            </a:r>
+          </a:p>
+          <a:p>
+            <a:r>
+              <a:t>still have no source, an NX journal and a bill of materials.</a:t>
+            </a:r>
+          </a:p>
+          <a:p>
+            <a:r>
+              <a:t>We are not giving week-by-week dates because we have not fixed them.</a:t>
+            </a:r>
+          </a:p>
+        </p:txBody>
+      </p:sp>
+      <p:sp>
+        <p:nvSpPr>
+          <p:cNvPr id="4" name="Slide Number Placeholder 3"/>
+          <p:cNvSpPr>
+            <a:spLocks noGrp="1"/>
+          </p:cNvSpPr>
+          <p:nvPr>
+            <p:ph type="sldNum" idx="5" sz="quarter"/>
+          </p:nvPr>
+        </p:nvSpPr>
+        <p:spPr/>
+      </p:sp>
+    </p:spTree>
+  </p:cSld>
+  <p:clrMapOvr>
+    <a:masterClrMapping/>
+  </p:clrMapOvr>
+</p:notes>
+</file>
+
+<file path=ppt/notesSlides/notesSlide29.xml><?xml version="1.0" encoding="utf-8"?>
 <p:notes xmlns:a="http://schemas.openxmlformats.org/drawingml/2006/main" xmlns:p="http://schemas.openxmlformats.org/presentationml/2006/main" xmlns:r="http://schemas.openxmlformats.org/officeDocument/2006/relationships">
   <p:cSld>
     <p:spTree>
@@ -6761,6 +7129,132 @@
 </p:sld>
 </file>
 
+<file path=ppt/slides/slide27.xml><?xml version="1.0" encoding="utf-8"?>
+<p:sld xmlns:a="http://schemas.openxmlformats.org/drawingml/2006/main" xmlns:p="http://schemas.openxmlformats.org/presentationml/2006/main" xmlns:r="http://schemas.openxmlformats.org/officeDocument/2006/relationships">
+  <p:cSld>
+    <p:spTree>
+      <p:nvGrpSpPr>
+        <p:cNvPr id="1" name=""/>
+        <p:cNvGrpSpPr/>
+        <p:nvPr/>
+      </p:nvGrpSpPr>
+      <p:grpSpPr/>
+      <p:pic>
+        <p:nvPicPr>
+          <p:cNvPr id="2" name="Picture 1" descr="s-27.png"/>
+          <p:cNvPicPr>
+            <a:picLocks noChangeAspect="1"/>
+          </p:cNvPicPr>
+          <p:nvPr/>
+        </p:nvPicPr>
+        <p:blipFill>
+          <a:blip r:embed="rId2"/>
+          <a:stretch>
+            <a:fillRect/>
+          </a:stretch>
+        </p:blipFill>
+        <p:spPr>
+          <a:xfrm>
+            <a:off x="0" y="0"/>
+            <a:ext cx="12191695" cy="6858000"/>
+          </a:xfrm>
+          <a:prstGeom prst="rect">
+            <a:avLst/>
+          </a:prstGeom>
+        </p:spPr>
+      </p:pic>
+    </p:spTree>
+  </p:cSld>
+  <p:clrMapOvr>
+    <a:masterClrMapping/>
+  </p:clrMapOvr>
+</p:sld>
+</file>
+
+<file path=ppt/slides/slide28.xml><?xml version="1.0" encoding="utf-8"?>
+<p:sld xmlns:a="http://schemas.openxmlformats.org/drawingml/2006/main" xmlns:p="http://schemas.openxmlformats.org/presentationml/2006/main" xmlns:r="http://schemas.openxmlformats.org/officeDocument/2006/relationships">
+  <p:cSld>
+    <p:spTree>
+      <p:nvGrpSpPr>
+        <p:cNvPr id="1" name=""/>
+        <p:cNvGrpSpPr/>
+        <p:nvPr/>
+      </p:nvGrpSpPr>
+      <p:grpSpPr/>
+      <p:pic>
+        <p:nvPicPr>
+          <p:cNvPr id="2" name="Picture 1" descr="s-28.png"/>
+          <p:cNvPicPr>
+            <a:picLocks noChangeAspect="1"/>
+          </p:cNvPicPr>
+          <p:nvPr/>
+        </p:nvPicPr>
+        <p:blipFill>
+          <a:blip r:embed="rId2"/>
+          <a:stretch>
+            <a:fillRect/>
+          </a:stretch>
+        </p:blipFill>
+        <p:spPr>
+          <a:xfrm>
+            <a:off x="0" y="0"/>
+            <a:ext cx="12191695" cy="6858000"/>
+          </a:xfrm>
+          <a:prstGeom prst="rect">
+            <a:avLst/>
+          </a:prstGeom>
+        </p:spPr>
+      </p:pic>
+    </p:spTree>
+  </p:cSld>
+  <p:clrMapOvr>
+    <a:masterClrMapping/>
+  </p:clrMapOvr>
+</p:sld>
+</file>
+
+<file path=ppt/slides/slide29.xml><?xml version="1.0" encoding="utf-8"?>
+<p:sld xmlns:a="http://schemas.openxmlformats.org/drawingml/2006/main" xmlns:p="http://schemas.openxmlformats.org/presentationml/2006/main" xmlns:r="http://schemas.openxmlformats.org/officeDocument/2006/relationships">
+  <p:cSld>
+    <p:spTree>
+      <p:nvGrpSpPr>
+        <p:cNvPr id="1" name=""/>
+        <p:cNvGrpSpPr/>
+        <p:nvPr/>
+      </p:nvGrpSpPr>
+      <p:grpSpPr/>
+      <p:pic>
+        <p:nvPicPr>
+          <p:cNvPr id="2" name="Picture 1" descr="s-29.png"/>
+          <p:cNvPicPr>
+            <a:picLocks noChangeAspect="1"/>
+          </p:cNvPicPr>
+          <p:nvPr/>
+        </p:nvPicPr>
+        <p:blipFill>
+          <a:blip r:embed="rId2"/>
+          <a:stretch>
+            <a:fillRect/>
+          </a:stretch>
+        </p:blipFill>
+        <p:spPr>
+          <a:xfrm>
+            <a:off x="0" y="0"/>
+            <a:ext cx="12191695" cy="6858000"/>
+          </a:xfrm>
+          <a:prstGeom prst="rect">
+            <a:avLst/>
+          </a:prstGeom>
+        </p:spPr>
+      </p:pic>
+    </p:spTree>
+  </p:cSld>
+  <p:clrMapOvr>
+    <a:masterClrMapping/>
+  </p:clrMapOvr>
+</p:sld>
+</file>
+
 <file path=ppt/slides/slide3.xml><?xml version="1.0" encoding="utf-8"?>
 <p:sld xmlns:a="http://schemas.openxmlformats.org/drawingml/2006/main" xmlns:p="http://schemas.openxmlformats.org/presentationml/2006/main" xmlns:r="http://schemas.openxmlformats.org/officeDocument/2006/relationships">
   <p:cSld>

</xml_diff>

<commit_message>
Rebuild the report, deck and notes from the redeployed site
Screenshots are now tracked, since a gitignored folder is why the report could not be rebuilt off the Mac. Objective counts in the deck and notes now match the report.
</commit_message>
<xml_diff>
--- a/report/AI-in-CAD-Major-Project-Presentation.pptx
+++ b/report/AI-in-CAD-Major-Project-Presentation.pptx
@@ -34,6 +34,7 @@
     <p:sldId id="282" r:id="rId34"/>
     <p:sldId id="283" r:id="rId35"/>
     <p:sldId id="284" r:id="rId36"/>
+    <p:sldId id="285" r:id="rId37"/>
   </p:sldIdLst>
   <p:sldSz cx="12191695" cy="6858000" type="screen4x3"/>
   <p:notesSz cx="6858000" cy="9144000"/>
@@ -825,7 +826,7 @@
           </a:p>
           <a:p>
             <a:r>
-              <a:t>The pin is sized twice. Double shear asks for 25.75. Bending asks for 43.72. We take the larger,</a:t>
+              <a:t>The pin is sized twice. Double shear asks for 25.75. Bending asks for 43.95. We take the larger,</a:t>
             </a:r>
           </a:p>
           <a:p>
@@ -1890,7 +1891,7 @@
           </a:p>
           <a:p>
             <a:r>
-              <a:t>The page refutes itself, and it is out by a factor of ten.</a:t>
+              <a:t>The page refutes itself, and it is out by a factor of one hundred.</a:t>
             </a:r>
           </a:p>
           <a:p>
@@ -2285,7 +2286,7 @@
           </a:p>
           <a:p>
             <a:r>
-              <a:t>so no tolerances or fits, which means the sheet is not yet a manufacturing drawing. Two of the</a:t>
+              <a:t>so no tolerances or fits, which means the sheet is not yet a manufacturing drawing. Three of the</a:t>
             </a:r>
           </a:p>
           <a:p>
@@ -2390,32 +2391,32 @@
           </a:p>
           <a:p>
             <a:r>
-              <a:t>Five of six are met without qualification: reading plain English, sizing and verifying with</a:t>
-            </a:r>
-          </a:p>
-          <a:p>
-            <a:r>
-              <a:t>iteration, the drawing sheet, verification against literature, and browser use without install.</a:t>
-            </a:r>
-          </a:p>
-          <a:p>
-            <a:r>
-              <a:t>The sixth, opening the exported file inside NX10 itself, is met in structure, AP214 schema, four</a:t>
-            </a:r>
-          </a:p>
-          <a:p>
-            <a:r>
-              <a:t>separate solids, but not yet confirmed by watching it actually open there.</a:t>
-            </a:r>
-          </a:p>
-          <a:p>
-            <a:r>
-              <a:t>If asked why show this at all instead of just claiming six for six: because recording the gap</a:t>
-            </a:r>
-          </a:p>
-          <a:p>
-            <a:r>
-              <a:t>honestly is itself part of what Objective 5 asked for. A scorecard that hides its one open item</a:t>
+              <a:t>Three are met without qualification: reading plain English, sizing and verifying with</a:t>
+            </a:r>
+          </a:p>
+          <a:p>
+            <a:r>
+              <a:t>iteration, and browser use without install. Three are met in part: the NX10 import is right in</a:t>
+            </a:r>
+          </a:p>
+          <a:p>
+            <a:r>
+              <a:t>structure, AP214 with each part its own solid, but not yet watched opening in the lab; the sheet</a:t>
+            </a:r>
+          </a:p>
+          <a:p>
+            <a:r>
+              <a:t>has projection and layout but no tolerances; and two joints are only partly verified.</a:t>
+            </a:r>
+          </a:p>
+          <a:p>
+            <a:r>
+              <a:t>If asked why show this at all instead of just claiming six for six: because recording the gaps</a:t>
+            </a:r>
+          </a:p>
+          <a:p>
+            <a:r>
+              <a:t>honestly is itself part of what Objective 5 asked for. A scorecard that hides its open items</a:t>
             </a:r>
           </a:p>
           <a:p>
@@ -2615,42 +2616,37 @@
           <a:lstStyle/>
           <a:p>
             <a:r>
-              <a:t>ANKUR.</a:t>
-            </a:r>
-          </a:p>
-          <a:p>
-            <a:r>
-              <a:t>To close.</a:t>
-            </a:r>
-          </a:p>
-          <a:p>
-            <a:r>
-              <a:t>Every dimension this software produces can be traced to a formula, and every formula to a page</a:t>
-            </a:r>
-          </a:p>
-          <a:p>
-            <a:r>
-              <a:t>in a book. That is the difference between a tool that designs and one that only draws.</a:t>
-            </a:r>
-          </a:p>
-          <a:p>
-            <a:r>
-              <a:t>The language model reads the requirement. The engineering stays deterministic, checked, and open</a:t>
-            </a:r>
-          </a:p>
-          <a:p>
-            <a:r>
-              <a:t>to inspection.</a:t>
-            </a:r>
-          </a:p>
-          <a:p>
-            <a:r>
-              <a:t>Six joints, 44 checks, 290 tests, and three errors found in published literature along the way.</a:t>
-            </a:r>
-          </a:p>
-          <a:p>
-            <a:r>
-              <a:t>Thank you. We are happy to take questions.</a:t>
+              <a:t>ATISHAY.</a:t>
+            </a:r>
+          </a:p>
+          <a:p>
+            <a:r>
+              <a:t>If you are asked whether this is a PINN, or where the AI is, use this slide.</a:t>
+            </a:r>
+          </a:p>
+          <a:p>
+            <a:r>
+              <a:t>Say: the language model reads the sentence and nothing else. Every dimension comes from the</a:t>
+            </a:r>
+          </a:p>
+          <a:p>
+            <a:r>
+              <a:t>mechanics equations on the screen, and every one of the nine failure modes is checked.</a:t>
+            </a:r>
+          </a:p>
+          <a:p>
+            <a:r>
+              <a:t>A PINN is a neural network that gets penalised when it breaks physics, so it is usually right.</a:t>
+            </a:r>
+          </a:p>
+          <a:p>
+            <a:r>
+              <a:t>Here physics is not a penalty, it is the calculation, so it cannot be wrong in that way.</a:t>
+            </a:r>
+          </a:p>
+          <a:p>
+            <a:r>
+              <a:t>If a check fails, the part grows a millimetre and every check runs again.</a:t>
             </a:r>
           </a:p>
         </p:txBody>
@@ -2761,6 +2757,111 @@
           <a:p>
             <a:r>
               <a:t>Our aim: keep every formula exactly as the textbook has it, and remove only the repetition.</a:t>
+            </a:r>
+          </a:p>
+        </p:txBody>
+      </p:sp>
+      <p:sp>
+        <p:nvSpPr>
+          <p:cNvPr id="4" name="Slide Number Placeholder 3"/>
+          <p:cNvSpPr>
+            <a:spLocks noGrp="1"/>
+          </p:cNvSpPr>
+          <p:nvPr>
+            <p:ph type="sldNum" idx="5" sz="quarter"/>
+          </p:nvPr>
+        </p:nvSpPr>
+        <p:spPr/>
+      </p:sp>
+    </p:spTree>
+  </p:cSld>
+  <p:clrMapOvr>
+    <a:masterClrMapping/>
+  </p:clrMapOvr>
+</p:notes>
+</file>
+
+<file path=ppt/notesSlides/notesSlide30.xml><?xml version="1.0" encoding="utf-8"?>
+<p:notes xmlns:a="http://schemas.openxmlformats.org/drawingml/2006/main" xmlns:p="http://schemas.openxmlformats.org/presentationml/2006/main" xmlns:r="http://schemas.openxmlformats.org/officeDocument/2006/relationships">
+  <p:cSld>
+    <p:spTree>
+      <p:nvGrpSpPr>
+        <p:cNvPr id="1" name=""/>
+        <p:cNvGrpSpPr/>
+        <p:nvPr/>
+      </p:nvGrpSpPr>
+      <p:grpSpPr>
+        <a:xfrm>
+          <a:off x="0" y="0"/>
+          <a:ext cx="0" cy="0"/>
+          <a:chOff x="0" y="0"/>
+          <a:chExt cx="0" cy="0"/>
+        </a:xfrm>
+      </p:grpSpPr>
+      <p:sp>
+        <p:nvSpPr>
+          <p:cNvPr id="2" name="Slide Image Placeholder 1"/>
+          <p:cNvSpPr>
+            <a:spLocks noGrp="1"/>
+          </p:cNvSpPr>
+          <p:nvPr>
+            <p:ph type="sldImg" idx="2"/>
+          </p:nvPr>
+        </p:nvSpPr>
+        <p:spPr/>
+      </p:sp>
+      <p:sp>
+        <p:nvSpPr>
+          <p:cNvPr id="3" name="Notes Placeholder 2"/>
+          <p:cNvSpPr>
+            <a:spLocks noGrp="1"/>
+          </p:cNvSpPr>
+          <p:nvPr>
+            <p:ph type="body" idx="3" sz="quarter"/>
+          </p:nvPr>
+        </p:nvSpPr>
+        <p:spPr/>
+        <p:txBody>
+          <a:bodyPr/>
+          <a:lstStyle/>
+          <a:p>
+            <a:r>
+              <a:t>ANKUR.</a:t>
+            </a:r>
+          </a:p>
+          <a:p>
+            <a:r>
+              <a:t>To close.</a:t>
+            </a:r>
+          </a:p>
+          <a:p>
+            <a:r>
+              <a:t>Every dimension this software produces can be traced to a formula, and every formula to a page</a:t>
+            </a:r>
+          </a:p>
+          <a:p>
+            <a:r>
+              <a:t>in a book. That is the difference between a tool that designs and one that only draws.</a:t>
+            </a:r>
+          </a:p>
+          <a:p>
+            <a:r>
+              <a:t>The language model reads the requirement. The engineering stays deterministic, checked, and open</a:t>
+            </a:r>
+          </a:p>
+          <a:p>
+            <a:r>
+              <a:t>to inspection.</a:t>
+            </a:r>
+          </a:p>
+          <a:p>
+            <a:r>
+              <a:t>Six joints, 44 checks, 290 tests, and three errors found in published literature along the way.</a:t>
+            </a:r>
+          </a:p>
+          <a:p>
+            <a:r>
+              <a:t>Thank you. We are happy to take questions.</a:t>
             </a:r>
           </a:p>
         </p:txBody>
@@ -7297,6 +7398,48 @@
 </p:sld>
 </file>
 
+<file path=ppt/slides/slide30.xml><?xml version="1.0" encoding="utf-8"?>
+<p:sld xmlns:a="http://schemas.openxmlformats.org/drawingml/2006/main" xmlns:p="http://schemas.openxmlformats.org/presentationml/2006/main" xmlns:r="http://schemas.openxmlformats.org/officeDocument/2006/relationships">
+  <p:cSld>
+    <p:spTree>
+      <p:nvGrpSpPr>
+        <p:cNvPr id="1" name=""/>
+        <p:cNvGrpSpPr/>
+        <p:nvPr/>
+      </p:nvGrpSpPr>
+      <p:grpSpPr/>
+      <p:pic>
+        <p:nvPicPr>
+          <p:cNvPr id="2" name="Picture 1" descr="s-30.png"/>
+          <p:cNvPicPr>
+            <a:picLocks noChangeAspect="1"/>
+          </p:cNvPicPr>
+          <p:nvPr/>
+        </p:nvPicPr>
+        <p:blipFill>
+          <a:blip r:embed="rId2"/>
+          <a:stretch>
+            <a:fillRect/>
+          </a:stretch>
+        </p:blipFill>
+        <p:spPr>
+          <a:xfrm>
+            <a:off x="0" y="0"/>
+            <a:ext cx="12191695" cy="6858000"/>
+          </a:xfrm>
+          <a:prstGeom prst="rect">
+            <a:avLst/>
+          </a:prstGeom>
+        </p:spPr>
+      </p:pic>
+    </p:spTree>
+  </p:cSld>
+  <p:clrMapOvr>
+    <a:masterClrMapping/>
+  </p:clrMapOvr>
+</p:sld>
+</file>
+
 <file path=ppt/slides/slide4.xml><?xml version="1.0" encoding="utf-8"?>
 <p:sld xmlns:a="http://schemas.openxmlformats.org/drawingml/2006/main" xmlns:p="http://schemas.openxmlformats.org/presentationml/2006/main" xmlns:r="http://schemas.openxmlformats.org/officeDocument/2006/relationships">
   <p:cSld>

</xml_diff>

<commit_message>
Report, deck and notes follow the Bhandari based joints
Adds Bhandari to the literature and references, records the Ex 4.5 and Ex 4.2 reproduction and the one NPTEL disagreement, updates the knuckle numbers, and adds the team speaking pack generator.
</commit_message>
<xml_diff>
--- a/report/AI-in-CAD-Major-Project-Presentation.pptx
+++ b/report/AI-in-CAD-Major-Project-Presentation.pptx
@@ -2061,7 +2061,7 @@
           </a:p>
           <a:p>
             <a:r>
-              <a:t>On the knuckle eye rod: formula 52.0, computed 57.9, about 11.5 percent higher. That is expected,</a:t>
+              <a:t>On the knuckle eye rod: formula 52.0, computed 57.9, about 11.3 percent higher. That is expected,</a:t>
             </a:r>
           </a:p>
           <a:p>
@@ -2166,7 +2166,7 @@
           </a:p>
           <a:p>
             <a:r>
-              <a:t>290 automated tests run on every change: the arithmetic, the geometry, the parsing, the drawing</a:t>
+              <a:t>296 automated tests run on every change: the arithmetic, the geometry, the parsing, the drawing</a:t>
             </a:r>
           </a:p>
           <a:p>
@@ -2856,7 +2856,7 @@
           </a:p>
           <a:p>
             <a:r>
-              <a:t>Six joints, 44 checks, 290 tests, and three errors found in published literature along the way.</a:t>
+              <a:t>Six joints, 44 checks, 296 tests, and three errors found in published literature along the way.</a:t>
             </a:r>
           </a:p>
           <a:p>

</xml_diff>

<commit_message>
Add a per-presenter learners guide and rebuild the report set
One overview page, then a page per presenter: concepts, how they show up in aicad, viva
questions. Numbers come from facts() in the speaking pack. Report, deck, notes and viva prep
rebuilt on the Bhandari joints; test count is 301.
</commit_message>
<xml_diff>
--- a/report/AI-in-CAD-Major-Project-Presentation.pptx
+++ b/report/AI-in-CAD-Major-Project-Presentation.pptx
@@ -646,7 +646,7 @@
           </a:p>
           <a:p>
             <a:r>
-              <a:t>The busiest check across all six sits between 67 and 79 percent of allowable. That is</a:t>
+              <a:t>The busiest check across all six sits between 71 and 79 percent of allowable. That is</a:t>
             </a:r>
           </a:p>
           <a:p>
@@ -826,7 +826,7 @@
           </a:p>
           <a:p>
             <a:r>
-              <a:t>The pin is sized twice. Double shear asks for 25.75. Bending asks for 43.95. We take the larger,</a:t>
+              <a:t>The pin is sized twice. Double shear asks for 25.75. Bending asks for 44.85. We take the larger,</a:t>
             </a:r>
           </a:p>
           <a:p>
@@ -931,7 +931,7 @@
           </a:p>
           <a:p>
             <a:r>
-              <a:t>Nine of nine are satisfied. The busiest is shear of the eye at 76 percent of its allowable.</a:t>
+              <a:t>Nine of nine are satisfied. The busiest is the pin in bending at 79 percent of its allowable.</a:t>
             </a:r>
           </a:p>
           <a:p>

</xml_diff>